<commit_message>
Recreate all PowerPoint presentations with 16:9 widescreen format
Changes:
- Updated all 10 chapter presentations from square/4:3 to 16:9 widescreen
- New dimensions: 13.333" x 7.5" (standard widescreen ratio)
- Adjusted all slide layouts for proper widescreen display
- Updated positioning for titles, content, and spacing
- Added recreate_widescreen_pptx.py script for regeneration

All presentations now use the classic widescreen format that looks
great on modern displays and projectors.
</commit_message>
<xml_diff>
--- a/python_course/chapter_01_introduction/presentation.pptx
+++ b/python_course/chapter_01_introduction/presentation.pptx
@@ -16,7 +16,7 @@
     <p:sldId id="264" r:id="rId15"/>
     <p:sldId id="265" r:id="rId16"/>
   </p:sldIdLst>
-  <p:sldSz cx="9144000" cy="6858000" type="screen4x3"/>
+  <p:sldSz cx="12191695" cy="6858000" type="screen4x3"/>
   <p:notesSz cx="6858000" cy="9144000"/>
   <p:defaultTextStyle>
     <a:defPPr>
@@ -3090,14 +3090,6 @@
 <file path=ppt/slides/slide1.xml><?xml version="1.0" encoding="utf-8"?>
 <p:sld xmlns:a="http://schemas.openxmlformats.org/drawingml/2006/main" xmlns:p="http://schemas.openxmlformats.org/presentationml/2006/main" xmlns:r="http://schemas.openxmlformats.org/officeDocument/2006/relationships">
   <p:cSld>
-    <p:bg>
-      <p:bgPr>
-        <a:solidFill>
-          <a:srgbClr val="3B82F6"/>
-        </a:solidFill>
-        <a:effectLst/>
-      </p:bgPr>
-    </p:bg>
     <p:spTree>
       <p:nvGrpSpPr>
         <p:cNvPr id="1" name=""/>
@@ -3107,14 +3099,57 @@
       <p:grpSpPr/>
       <p:sp>
         <p:nvSpPr>
-          <p:cNvPr id="2" name="TextBox 1"/>
+          <p:cNvPr id="2" name="Rectangle 1"/>
+          <p:cNvSpPr/>
+          <p:nvPr/>
+        </p:nvSpPr>
+        <p:spPr>
+          <a:xfrm>
+            <a:off x="0" y="0"/>
+            <a:ext cx="12191695" cy="6858000"/>
+          </a:xfrm>
+          <a:prstGeom prst="rect">
+            <a:avLst/>
+          </a:prstGeom>
+          <a:solidFill>
+            <a:srgbClr val="F0F8FF"/>
+          </a:solidFill>
+          <a:ln>
+            <a:noFill/>
+          </a:ln>
+        </p:spPr>
+        <p:style>
+          <a:lnRef idx="1">
+            <a:schemeClr val="accent1"/>
+          </a:lnRef>
+          <a:fillRef idx="3">
+            <a:schemeClr val="accent1"/>
+          </a:fillRef>
+          <a:effectRef idx="2">
+            <a:schemeClr val="accent1"/>
+          </a:effectRef>
+          <a:fontRef idx="minor">
+            <a:schemeClr val="lt1"/>
+          </a:fontRef>
+        </p:style>
+        <p:txBody>
+          <a:bodyPr rtlCol="0" anchor="ctr"/>
+          <a:lstStyle/>
+          <a:p>
+            <a:pPr algn="ctr"/>
+          </a:p>
+        </p:txBody>
+      </p:sp>
+      <p:sp>
+        <p:nvSpPr>
+          <p:cNvPr id="3" name="TextBox 2"/>
           <p:cNvSpPr txBox="1"/>
           <p:nvPr/>
         </p:nvSpPr>
         <p:spPr>
           <a:xfrm>
-            <a:off x="457200" y="2286000"/>
-            <a:ext cx="8229600" cy="1371600"/>
+            <a:off x="914400" y="1828800"/>
+            <a:ext cx="10360152" cy="1371600"/>
           </a:xfrm>
           <a:prstGeom prst="rect">
             <a:avLst/>
@@ -3122,7 +3157,7 @@
           <a:noFill/>
         </p:spPr>
         <p:txBody>
-          <a:bodyPr wrap="square">
+          <a:bodyPr wrap="none">
             <a:spAutoFit/>
           </a:bodyPr>
           <a:lstStyle/>
@@ -3130,26 +3165,26 @@
             <a:pPr algn="ctr">
               <a:defRPr sz="5400" b="1">
                 <a:solidFill>
-                  <a:srgbClr val="FFFFFF"/>
+                  <a:srgbClr val="003366"/>
                 </a:solidFill>
               </a:defRPr>
             </a:pPr>
             <a:r>
-              <a:t>Chapter 1: Introduction to Python</a:t>
-            </a:r>
-          </a:p>
-        </p:txBody>
-      </p:sp>
-      <p:sp>
-        <p:nvSpPr>
-          <p:cNvPr id="3" name="TextBox 2"/>
+              <a:t>Chapter 1</a:t>
+            </a:r>
+          </a:p>
+        </p:txBody>
+      </p:sp>
+      <p:sp>
+        <p:nvSpPr>
+          <p:cNvPr id="4" name="TextBox 3"/>
           <p:cNvSpPr txBox="1"/>
           <p:nvPr/>
         </p:nvSpPr>
         <p:spPr>
           <a:xfrm>
-            <a:off x="457200" y="3840480"/>
-            <a:ext cx="8229600" cy="731520"/>
+            <a:off x="914400" y="3657600"/>
+            <a:ext cx="10360152" cy="548640"/>
           </a:xfrm>
           <a:prstGeom prst="rect">
             <a:avLst/>
@@ -3163,9 +3198,44 @@
           <a:lstStyle/>
           <a:p>
             <a:pPr algn="ctr">
-              <a:defRPr sz="3200">
-                <a:solidFill>
-                  <a:srgbClr val="FFFFFF"/>
+              <a:defRPr sz="2800">
+                <a:solidFill>
+                  <a:srgbClr val="4682B4"/>
+                </a:solidFill>
+              </a:defRPr>
+            </a:pPr>
+            <a:r>
+              <a:t>Introduction to Python</a:t>
+            </a:r>
+          </a:p>
+        </p:txBody>
+      </p:sp>
+      <p:sp>
+        <p:nvSpPr>
+          <p:cNvPr id="5" name="TextBox 4"/>
+          <p:cNvSpPr txBox="1"/>
+          <p:nvPr/>
+        </p:nvSpPr>
+        <p:spPr>
+          <a:xfrm>
+            <a:off x="914400" y="4297680"/>
+            <a:ext cx="10360152" cy="548640"/>
+          </a:xfrm>
+          <a:prstGeom prst="rect">
+            <a:avLst/>
+          </a:prstGeom>
+          <a:noFill/>
+        </p:spPr>
+        <p:txBody>
+          <a:bodyPr wrap="none">
+            <a:spAutoFit/>
+          </a:bodyPr>
+          <a:lstStyle/>
+          <a:p>
+            <a:pPr algn="ctr">
+              <a:defRPr sz="2800">
+                <a:solidFill>
+                  <a:srgbClr val="4682B4"/>
                 </a:solidFill>
               </a:defRPr>
             </a:pPr>
@@ -3186,14 +3256,6 @@
 <file path=ppt/slides/slide10.xml><?xml version="1.0" encoding="utf-8"?>
 <p:sld xmlns:a="http://schemas.openxmlformats.org/drawingml/2006/main" xmlns:p="http://schemas.openxmlformats.org/presentationml/2006/main" xmlns:r="http://schemas.openxmlformats.org/officeDocument/2006/relationships">
   <p:cSld>
-    <p:bg>
-      <p:bgPr>
-        <a:solidFill>
-          <a:srgbClr val="3B82F6"/>
-        </a:solidFill>
-        <a:effectLst/>
-      </p:bgPr>
-    </p:bg>
     <p:spTree>
       <p:nvGrpSpPr>
         <p:cNvPr id="1" name=""/>
@@ -3203,14 +3265,57 @@
       <p:grpSpPr/>
       <p:sp>
         <p:nvSpPr>
-          <p:cNvPr id="2" name="TextBox 1"/>
+          <p:cNvPr id="2" name="Rectangle 1"/>
+          <p:cNvSpPr/>
+          <p:nvPr/>
+        </p:nvSpPr>
+        <p:spPr>
+          <a:xfrm>
+            <a:off x="0" y="0"/>
+            <a:ext cx="12191695" cy="6858000"/>
+          </a:xfrm>
+          <a:prstGeom prst="rect">
+            <a:avLst/>
+          </a:prstGeom>
+          <a:solidFill>
+            <a:srgbClr val="F0F8FF"/>
+          </a:solidFill>
+          <a:ln>
+            <a:noFill/>
+          </a:ln>
+        </p:spPr>
+        <p:style>
+          <a:lnRef idx="1">
+            <a:schemeClr val="accent1"/>
+          </a:lnRef>
+          <a:fillRef idx="3">
+            <a:schemeClr val="accent1"/>
+          </a:fillRef>
+          <a:effectRef idx="2">
+            <a:schemeClr val="accent1"/>
+          </a:effectRef>
+          <a:fontRef idx="minor">
+            <a:schemeClr val="lt1"/>
+          </a:fontRef>
+        </p:style>
+        <p:txBody>
+          <a:bodyPr rtlCol="0" anchor="ctr"/>
+          <a:lstStyle/>
+          <a:p>
+            <a:pPr algn="ctr"/>
+          </a:p>
+        </p:txBody>
+      </p:sp>
+      <p:sp>
+        <p:nvSpPr>
+          <p:cNvPr id="3" name="TextBox 2"/>
           <p:cNvSpPr txBox="1"/>
           <p:nvPr/>
         </p:nvSpPr>
         <p:spPr>
           <a:xfrm>
             <a:off x="914400" y="1828800"/>
-            <a:ext cx="7315200" cy="1371600"/>
+            <a:ext cx="10360152" cy="1371600"/>
           </a:xfrm>
           <a:prstGeom prst="rect">
             <a:avLst/>
@@ -3224,28 +3329,28 @@
           <a:lstStyle/>
           <a:p>
             <a:pPr algn="ctr">
-              <a:defRPr sz="6000" b="1">
-                <a:solidFill>
-                  <a:srgbClr val="FFFFFF"/>
+              <a:defRPr sz="5400" b="1">
+                <a:solidFill>
+                  <a:srgbClr val="003366"/>
                 </a:solidFill>
               </a:defRPr>
             </a:pPr>
             <a:r>
-              <a:t>Practice Time!</a:t>
-            </a:r>
-          </a:p>
-        </p:txBody>
-      </p:sp>
-      <p:sp>
-        <p:nvSpPr>
-          <p:cNvPr id="3" name="TextBox 2"/>
+              <a:t>Ready to Code!</a:t>
+            </a:r>
+          </a:p>
+        </p:txBody>
+      </p:sp>
+      <p:sp>
+        <p:nvSpPr>
+          <p:cNvPr id="4" name="TextBox 3"/>
           <p:cNvSpPr txBox="1"/>
           <p:nvPr/>
         </p:nvSpPr>
         <p:spPr>
           <a:xfrm>
-            <a:off x="914400" y="3474720"/>
-            <a:ext cx="7315200" cy="914400"/>
+            <a:off x="914400" y="3657600"/>
+            <a:ext cx="10360152" cy="548640"/>
           </a:xfrm>
           <a:prstGeom prst="rect">
             <a:avLst/>
@@ -3261,73 +3366,47 @@
             <a:pPr algn="ctr">
               <a:defRPr sz="2800">
                 <a:solidFill>
-                  <a:srgbClr val="FFFFFF"/>
+                  <a:srgbClr val="4682B4"/>
                 </a:solidFill>
               </a:defRPr>
             </a:pPr>
             <a:r>
-              <a:t>Try creating your own variables,</a:t>
-            </a:r>
-          </a:p>
-          <a:p>
-            <a:pPr algn="ctr">
-              <a:defRPr sz="2800">
-                <a:solidFill>
-                  <a:srgbClr val="FFFFFF"/>
-                </a:solidFill>
-              </a:defRPr>
-            </a:pPr>
-            <a:r>
-              <a:t>performing calculations,</a:t>
-            </a:r>
-          </a:p>
-          <a:p>
-            <a:pPr algn="ctr">
-              <a:defRPr sz="2800">
-                <a:solidFill>
-                  <a:srgbClr val="FFFFFF"/>
-                </a:solidFill>
-              </a:defRPr>
-            </a:pPr>
-            <a:r>
-              <a:t>and printing the results!</a:t>
-            </a:r>
-          </a:p>
-        </p:txBody>
-      </p:sp>
-      <p:sp>
-        <p:nvSpPr>
-          <p:cNvPr id="4" name="TextBox 3"/>
+              <a:t>Open the practice notebook and start experimenting</a:t>
+            </a:r>
+          </a:p>
+        </p:txBody>
+      </p:sp>
+      <p:sp>
+        <p:nvSpPr>
+          <p:cNvPr id="5" name="TextBox 4"/>
           <p:cNvSpPr txBox="1"/>
           <p:nvPr/>
         </p:nvSpPr>
         <p:spPr>
           <a:xfrm>
-            <a:off x="2286000" y="5029200"/>
-            <a:ext cx="4572000" cy="731520"/>
+            <a:off x="914400" y="4297680"/>
+            <a:ext cx="10360152" cy="548640"/>
           </a:xfrm>
           <a:prstGeom prst="rect">
             <a:avLst/>
           </a:prstGeom>
-          <a:solidFill>
-            <a:srgbClr val="FFFFFF"/>
-          </a:solidFill>
-        </p:spPr>
-        <p:txBody>
-          <a:bodyPr wrap="none" anchor="ctr">
+          <a:noFill/>
+        </p:spPr>
+        <p:txBody>
+          <a:bodyPr wrap="none">
             <a:spAutoFit/>
           </a:bodyPr>
           <a:lstStyle/>
           <a:p>
             <a:pPr algn="ctr">
-              <a:defRPr sz="2400" b="1">
-                <a:solidFill>
-                  <a:srgbClr val="3B82F6"/>
+              <a:defRPr sz="2800">
+                <a:solidFill>
+                  <a:srgbClr val="4682B4"/>
                 </a:solidFill>
               </a:defRPr>
             </a:pPr>
             <a:r>
-              <a:t>Open your Python environment and code!</a:t>
+              <a:t>Remember: The best way to learn is by doing! 💪</a:t>
             </a:r>
           </a:p>
         </p:txBody>
@@ -3343,14 +3422,6 @@
 <file path=ppt/slides/slide2.xml><?xml version="1.0" encoding="utf-8"?>
 <p:sld xmlns:a="http://schemas.openxmlformats.org/drawingml/2006/main" xmlns:p="http://schemas.openxmlformats.org/presentationml/2006/main" xmlns:r="http://schemas.openxmlformats.org/officeDocument/2006/relationships">
   <p:cSld>
-    <p:bg>
-      <p:bgPr>
-        <a:solidFill>
-          <a:srgbClr val="FFFFFF"/>
-        </a:solidFill>
-        <a:effectLst/>
-      </p:bgPr>
-    </p:bg>
     <p:spTree>
       <p:nvGrpSpPr>
         <p:cNvPr id="1" name=""/>
@@ -3360,95 +3431,87 @@
       <p:grpSpPr/>
       <p:sp>
         <p:nvSpPr>
-          <p:cNvPr id="2" name="TextBox 1"/>
-          <p:cNvSpPr txBox="1"/>
+          <p:cNvPr id="2" name="Rectangle 1"/>
+          <p:cNvSpPr/>
           <p:nvPr/>
         </p:nvSpPr>
         <p:spPr>
           <a:xfrm>
             <a:off x="0" y="0"/>
-            <a:ext cx="9144000" cy="1097280"/>
+            <a:ext cx="12191695" cy="6858000"/>
           </a:xfrm>
           <a:prstGeom prst="rect">
             <a:avLst/>
           </a:prstGeom>
           <a:solidFill>
-            <a:srgbClr val="3B82F6"/>
+            <a:srgbClr val="FFFFFF"/>
           </a:solidFill>
-        </p:spPr>
-        <p:txBody>
-          <a:bodyPr wrap="none" tIns="182880">
-            <a:spAutoFit/>
-          </a:bodyPr>
-          <a:lstStyle/>
-          <a:p>
-            <a:pPr algn="ctr">
-              <a:defRPr sz="4400" b="1">
-                <a:solidFill>
-                  <a:srgbClr val="FFFFFF"/>
-                </a:solidFill>
-              </a:defRPr>
-            </a:pPr>
-            <a:r>
-              <a:t>What is Programming?</a:t>
-            </a:r>
-          </a:p>
-        </p:txBody>
-      </p:sp>
-      <p:sp>
-        <p:nvSpPr>
-          <p:cNvPr id="3" name="TextBox 2"/>
-          <p:cNvSpPr txBox="1"/>
+          <a:ln>
+            <a:noFill/>
+          </a:ln>
+        </p:spPr>
+        <p:style>
+          <a:lnRef idx="1">
+            <a:schemeClr val="accent1"/>
+          </a:lnRef>
+          <a:fillRef idx="3">
+            <a:schemeClr val="accent1"/>
+          </a:fillRef>
+          <a:effectRef idx="2">
+            <a:schemeClr val="accent1"/>
+          </a:effectRef>
+          <a:fontRef idx="minor">
+            <a:schemeClr val="lt1"/>
+          </a:fontRef>
+        </p:style>
+        <p:txBody>
+          <a:bodyPr rtlCol="0" anchor="ctr"/>
+          <a:lstStyle/>
+          <a:p>
+            <a:pPr algn="ctr"/>
+          </a:p>
+        </p:txBody>
+      </p:sp>
+      <p:sp>
+        <p:nvSpPr>
+          <p:cNvPr id="3" name="Rectangle 2"/>
+          <p:cNvSpPr/>
           <p:nvPr/>
         </p:nvSpPr>
         <p:spPr>
           <a:xfrm>
-            <a:off x="914400" y="1828800"/>
-            <a:ext cx="7315200" cy="1188720"/>
+            <a:off x="0" y="0"/>
+            <a:ext cx="12191695" cy="137160"/>
           </a:xfrm>
           <a:prstGeom prst="rect">
             <a:avLst/>
           </a:prstGeom>
           <a:solidFill>
-            <a:srgbClr val="DBEAFE"/>
+            <a:srgbClr val="0066CC"/>
           </a:solidFill>
-          <a:ln w="25400">
-            <a:solidFill>
-              <a:srgbClr val="3B82F6"/>
-            </a:solidFill>
+          <a:ln>
+            <a:noFill/>
           </a:ln>
         </p:spPr>
-        <p:txBody>
-          <a:bodyPr wrap="square" lIns="182880" tIns="91440">
-            <a:spAutoFit/>
-          </a:bodyPr>
-          <a:lstStyle/>
-          <a:p>
-            <a:pPr>
-              <a:defRPr sz="2400" b="1">
-                <a:solidFill>
-                  <a:srgbClr val="3B82F6"/>
-                </a:solidFill>
-              </a:defRPr>
-            </a:pPr>
-            <a:r>
-              <a:t>• Giving Instructions</a:t>
-            </a:r>
-          </a:p>
-          <a:p>
-            <a:pPr>
-              <a:spcBef>
-                <a:spcPts val="600"/>
-              </a:spcBef>
-              <a:defRPr sz="1800">
-                <a:solidFill>
-                  <a:srgbClr val="1E293B"/>
-                </a:solidFill>
-              </a:defRPr>
-            </a:pPr>
-            <a:r>
-              <a:t>Writing step-by-step commands for a computer to follow</a:t>
-            </a:r>
+        <p:style>
+          <a:lnRef idx="1">
+            <a:schemeClr val="accent1"/>
+          </a:lnRef>
+          <a:fillRef idx="3">
+            <a:schemeClr val="accent1"/>
+          </a:fillRef>
+          <a:effectRef idx="2">
+            <a:schemeClr val="accent1"/>
+          </a:effectRef>
+          <a:fontRef idx="minor">
+            <a:schemeClr val="lt1"/>
+          </a:fontRef>
+        </p:style>
+        <p:txBody>
+          <a:bodyPr rtlCol="0" anchor="ctr"/>
+          <a:lstStyle/>
+          <a:p>
+            <a:pPr algn="ctr"/>
           </a:p>
         </p:txBody>
       </p:sp>
@@ -3460,108 +3523,185 @@
         </p:nvSpPr>
         <p:spPr>
           <a:xfrm>
-            <a:off x="914400" y="3200400"/>
-            <a:ext cx="7315200" cy="1188720"/>
+            <a:off x="457200" y="365760"/>
+            <a:ext cx="10972800" cy="731520"/>
+          </a:xfrm>
+          <a:prstGeom prst="rect">
+            <a:avLst/>
+          </a:prstGeom>
+          <a:noFill/>
+        </p:spPr>
+        <p:txBody>
+          <a:bodyPr wrap="none">
+            <a:spAutoFit/>
+          </a:bodyPr>
+          <a:lstStyle/>
+          <a:p>
+            <a:pPr>
+              <a:defRPr sz="4000" b="1">
+                <a:solidFill>
+                  <a:srgbClr val="003366"/>
+                </a:solidFill>
+              </a:defRPr>
+            </a:pPr>
+            <a:r>
+              <a:t>What is Programming? 🤔</a:t>
+            </a:r>
+          </a:p>
+        </p:txBody>
+      </p:sp>
+      <p:sp>
+        <p:nvSpPr>
+          <p:cNvPr id="5" name="Rectangle 4"/>
+          <p:cNvSpPr/>
+          <p:nvPr/>
+        </p:nvSpPr>
+        <p:spPr>
+          <a:xfrm>
+            <a:off x="457200" y="1005840"/>
+            <a:ext cx="1828800" cy="45720"/>
           </a:xfrm>
           <a:prstGeom prst="rect">
             <a:avLst/>
           </a:prstGeom>
           <a:solidFill>
-            <a:srgbClr val="DBEAFE"/>
+            <a:srgbClr val="0066CC"/>
           </a:solidFill>
-          <a:ln w="25400">
-            <a:solidFill>
-              <a:srgbClr val="3B82F6"/>
-            </a:solidFill>
+          <a:ln>
+            <a:noFill/>
           </a:ln>
         </p:spPr>
-        <p:txBody>
-          <a:bodyPr wrap="square" lIns="182880" tIns="91440">
-            <a:spAutoFit/>
-          </a:bodyPr>
-          <a:lstStyle/>
-          <a:p>
-            <a:pPr>
-              <a:defRPr sz="2400" b="1">
-                <a:solidFill>
-                  <a:srgbClr val="3B82F6"/>
-                </a:solidFill>
-              </a:defRPr>
-            </a:pPr>
-            <a:r>
-              <a:t>• Solving Problems</a:t>
-            </a:r>
-          </a:p>
-          <a:p>
-            <a:pPr>
-              <a:spcBef>
-                <a:spcPts val="600"/>
-              </a:spcBef>
-              <a:defRPr sz="1800">
-                <a:solidFill>
-                  <a:srgbClr val="1E293B"/>
-                </a:solidFill>
-              </a:defRPr>
-            </a:pPr>
-            <a:r>
-              <a:t>Breaking down complex tasks into simple, logical steps</a:t>
-            </a:r>
-          </a:p>
-        </p:txBody>
-      </p:sp>
-      <p:sp>
-        <p:nvSpPr>
-          <p:cNvPr id="5" name="TextBox 4"/>
+        <p:style>
+          <a:lnRef idx="1">
+            <a:schemeClr val="accent1"/>
+          </a:lnRef>
+          <a:fillRef idx="3">
+            <a:schemeClr val="accent1"/>
+          </a:fillRef>
+          <a:effectRef idx="2">
+            <a:schemeClr val="accent1"/>
+          </a:effectRef>
+          <a:fontRef idx="minor">
+            <a:schemeClr val="lt1"/>
+          </a:fontRef>
+        </p:style>
+        <p:txBody>
+          <a:bodyPr rtlCol="0" anchor="ctr"/>
+          <a:lstStyle/>
+          <a:p>
+            <a:pPr algn="ctr"/>
+          </a:p>
+        </p:txBody>
+      </p:sp>
+      <p:sp>
+        <p:nvSpPr>
+          <p:cNvPr id="6" name="TextBox 5"/>
           <p:cNvSpPr txBox="1"/>
           <p:nvPr/>
         </p:nvSpPr>
         <p:spPr>
           <a:xfrm>
-            <a:off x="914400" y="4572000"/>
-            <a:ext cx="7315200" cy="1188720"/>
+            <a:off x="640080" y="1371600"/>
+            <a:ext cx="10789920" cy="4572000"/>
           </a:xfrm>
           <a:prstGeom prst="rect">
             <a:avLst/>
           </a:prstGeom>
-          <a:solidFill>
-            <a:srgbClr val="DBEAFE"/>
-          </a:solidFill>
-          <a:ln w="25400">
-            <a:solidFill>
-              <a:srgbClr val="3B82F6"/>
-            </a:solidFill>
-          </a:ln>
-        </p:spPr>
-        <p:txBody>
-          <a:bodyPr wrap="square" lIns="182880" tIns="91440">
+          <a:noFill/>
+        </p:spPr>
+        <p:txBody>
+          <a:bodyPr wrap="square">
             <a:spAutoFit/>
           </a:bodyPr>
           <a:lstStyle/>
           <a:p>
             <a:pPr>
-              <a:defRPr sz="2400" b="1">
-                <a:solidFill>
-                  <a:srgbClr val="3B82F6"/>
+              <a:spcAft>
+                <a:spcPts val="800"/>
+              </a:spcAft>
+              <a:defRPr sz="2000" b="1">
+                <a:solidFill>
+                  <a:srgbClr val="333333"/>
                 </a:solidFill>
               </a:defRPr>
             </a:pPr>
             <a:r>
-              <a:t>• Speaking Computer Language</a:t>
+              <a:t>Giving Instructions</a:t>
             </a:r>
           </a:p>
           <a:p>
             <a:pPr>
-              <a:spcBef>
-                <a:spcPts val="600"/>
-              </a:spcBef>
-              <a:defRPr sz="1800">
-                <a:solidFill>
-                  <a:srgbClr val="1E293B"/>
+              <a:spcAft>
+                <a:spcPts val="800"/>
+              </a:spcAft>
+              <a:defRPr sz="2000" b="1">
+                <a:solidFill>
+                  <a:srgbClr val="333333"/>
                 </a:solidFill>
               </a:defRPr>
             </a:pPr>
             <a:r>
-              <a:t>Using code to communicate your ideas to machines</a:t>
+              <a:t>Programming is like giving step-by-step instructions to a computer</a:t>
+            </a:r>
+          </a:p>
+          <a:p>
+            <a:pPr>
+              <a:spcAft>
+                <a:spcPts val="800"/>
+              </a:spcAft>
+              <a:defRPr sz="2000" b="1">
+                <a:solidFill>
+                  <a:srgbClr val="333333"/>
+                </a:solidFill>
+              </a:defRPr>
+            </a:pPr>
+            <a:r>
+              <a:t>Solving Problems</a:t>
+            </a:r>
+          </a:p>
+          <a:p>
+            <a:pPr>
+              <a:spcAft>
+                <a:spcPts val="800"/>
+              </a:spcAft>
+              <a:defRPr sz="2000" b="1">
+                <a:solidFill>
+                  <a:srgbClr val="333333"/>
+                </a:solidFill>
+              </a:defRPr>
+            </a:pPr>
+            <a:r>
+              <a:t>We use code to solve problems and automate tasks</a:t>
+            </a:r>
+          </a:p>
+          <a:p>
+            <a:pPr>
+              <a:spcAft>
+                <a:spcPts val="800"/>
+              </a:spcAft>
+              <a:defRPr sz="2000" b="1">
+                <a:solidFill>
+                  <a:srgbClr val="333333"/>
+                </a:solidFill>
+              </a:defRPr>
+            </a:pPr>
+            <a:r>
+              <a:t>Speaking Computer Language</a:t>
+            </a:r>
+          </a:p>
+          <a:p>
+            <a:pPr>
+              <a:spcAft>
+                <a:spcPts val="800"/>
+              </a:spcAft>
+              <a:defRPr sz="2000" b="1">
+                <a:solidFill>
+                  <a:srgbClr val="333333"/>
+                </a:solidFill>
+              </a:defRPr>
+            </a:pPr>
+            <a:r>
+              <a:t>Just like we speak English or Arabic, computers understand programming languages</a:t>
             </a:r>
           </a:p>
         </p:txBody>
@@ -3577,14 +3717,6 @@
 <file path=ppt/slides/slide3.xml><?xml version="1.0" encoding="utf-8"?>
 <p:sld xmlns:a="http://schemas.openxmlformats.org/drawingml/2006/main" xmlns:p="http://schemas.openxmlformats.org/presentationml/2006/main" xmlns:r="http://schemas.openxmlformats.org/officeDocument/2006/relationships">
   <p:cSld>
-    <p:bg>
-      <p:bgPr>
-        <a:solidFill>
-          <a:srgbClr val="FFFFFF"/>
-        </a:solidFill>
-        <a:effectLst/>
-      </p:bgPr>
-    </p:bg>
     <p:spTree>
       <p:nvGrpSpPr>
         <p:cNvPr id="1" name=""/>
@@ -3594,95 +3726,87 @@
       <p:grpSpPr/>
       <p:sp>
         <p:nvSpPr>
-          <p:cNvPr id="2" name="TextBox 1"/>
-          <p:cNvSpPr txBox="1"/>
+          <p:cNvPr id="2" name="Rectangle 1"/>
+          <p:cNvSpPr/>
           <p:nvPr/>
         </p:nvSpPr>
         <p:spPr>
           <a:xfrm>
             <a:off x="0" y="0"/>
-            <a:ext cx="9144000" cy="1097280"/>
+            <a:ext cx="12191695" cy="6858000"/>
           </a:xfrm>
           <a:prstGeom prst="rect">
             <a:avLst/>
           </a:prstGeom>
           <a:solidFill>
-            <a:srgbClr val="3B82F6"/>
+            <a:srgbClr val="FFFFFF"/>
           </a:solidFill>
-        </p:spPr>
-        <p:txBody>
-          <a:bodyPr wrap="none" tIns="182880">
-            <a:spAutoFit/>
-          </a:bodyPr>
-          <a:lstStyle/>
-          <a:p>
-            <a:pPr algn="ctr">
-              <a:defRPr sz="4400" b="1">
-                <a:solidFill>
-                  <a:srgbClr val="FFFFFF"/>
-                </a:solidFill>
-              </a:defRPr>
-            </a:pPr>
-            <a:r>
-              <a:t>Why Learn Python?</a:t>
-            </a:r>
-          </a:p>
-        </p:txBody>
-      </p:sp>
-      <p:sp>
-        <p:nvSpPr>
-          <p:cNvPr id="3" name="TextBox 2"/>
-          <p:cNvSpPr txBox="1"/>
+          <a:ln>
+            <a:noFill/>
+          </a:ln>
+        </p:spPr>
+        <p:style>
+          <a:lnRef idx="1">
+            <a:schemeClr val="accent1"/>
+          </a:lnRef>
+          <a:fillRef idx="3">
+            <a:schemeClr val="accent1"/>
+          </a:fillRef>
+          <a:effectRef idx="2">
+            <a:schemeClr val="accent1"/>
+          </a:effectRef>
+          <a:fontRef idx="minor">
+            <a:schemeClr val="lt1"/>
+          </a:fontRef>
+        </p:style>
+        <p:txBody>
+          <a:bodyPr rtlCol="0" anchor="ctr"/>
+          <a:lstStyle/>
+          <a:p>
+            <a:pPr algn="ctr"/>
+          </a:p>
+        </p:txBody>
+      </p:sp>
+      <p:sp>
+        <p:nvSpPr>
+          <p:cNvPr id="3" name="Rectangle 2"/>
+          <p:cNvSpPr/>
           <p:nvPr/>
         </p:nvSpPr>
         <p:spPr>
           <a:xfrm>
-            <a:off x="731520" y="1828800"/>
-            <a:ext cx="3566160" cy="1828800"/>
+            <a:off x="0" y="0"/>
+            <a:ext cx="12191695" cy="137160"/>
           </a:xfrm>
           <a:prstGeom prst="rect">
             <a:avLst/>
           </a:prstGeom>
           <a:solidFill>
-            <a:srgbClr val="DBEAFE"/>
+            <a:srgbClr val="0066CC"/>
           </a:solidFill>
-          <a:ln w="38100">
-            <a:solidFill>
-              <a:srgbClr val="3B82F6"/>
-            </a:solidFill>
+          <a:ln>
+            <a:noFill/>
           </a:ln>
         </p:spPr>
-        <p:txBody>
-          <a:bodyPr wrap="square" lIns="137160" rIns="137160" tIns="274320" anchor="t">
-            <a:spAutoFit/>
-          </a:bodyPr>
-          <a:lstStyle/>
-          <a:p>
-            <a:pPr algn="ctr">
-              <a:defRPr sz="2800" b="1">
-                <a:solidFill>
-                  <a:srgbClr val="3B82F6"/>
-                </a:solidFill>
-              </a:defRPr>
-            </a:pPr>
-            <a:r>
-              <a:t>Easy to Learn</a:t>
-            </a:r>
-          </a:p>
-          <a:p>
-            <a:pPr algn="ctr">
-              <a:spcBef>
-                <a:spcPts val="1200"/>
-              </a:spcBef>
-              <a:defRPr sz="1600">
-                <a:solidFill>
-                  <a:srgbClr val="1E293B"/>
-                </a:solidFill>
-              </a:defRPr>
-            </a:pPr>
-            <a:r>
-              <a:t>Simple syntax that reads like English</a:t>
-            </a:r>
+        <p:style>
+          <a:lnRef idx="1">
+            <a:schemeClr val="accent1"/>
+          </a:lnRef>
+          <a:fillRef idx="3">
+            <a:schemeClr val="accent1"/>
+          </a:fillRef>
+          <a:effectRef idx="2">
+            <a:schemeClr val="accent1"/>
+          </a:effectRef>
+          <a:fontRef idx="minor">
+            <a:schemeClr val="lt1"/>
+          </a:fontRef>
+        </p:style>
+        <p:txBody>
+          <a:bodyPr rtlCol="0" anchor="ctr"/>
+          <a:lstStyle/>
+          <a:p>
+            <a:pPr algn="ctr"/>
           </a:p>
         </p:txBody>
       </p:sp>
@@ -3694,145 +3818,195 @@
         </p:nvSpPr>
         <p:spPr>
           <a:xfrm>
-            <a:off x="4846320" y="1828800"/>
-            <a:ext cx="3566160" cy="1828800"/>
+            <a:off x="457200" y="365760"/>
+            <a:ext cx="10972800" cy="731520"/>
+          </a:xfrm>
+          <a:prstGeom prst="rect">
+            <a:avLst/>
+          </a:prstGeom>
+          <a:noFill/>
+        </p:spPr>
+        <p:txBody>
+          <a:bodyPr wrap="none">
+            <a:spAutoFit/>
+          </a:bodyPr>
+          <a:lstStyle/>
+          <a:p>
+            <a:pPr>
+              <a:defRPr sz="4000" b="1">
+                <a:solidFill>
+                  <a:srgbClr val="003366"/>
+                </a:solidFill>
+              </a:defRPr>
+            </a:pPr>
+            <a:r>
+              <a:t>Why Learn Python? 🐍</a:t>
+            </a:r>
+          </a:p>
+        </p:txBody>
+      </p:sp>
+      <p:sp>
+        <p:nvSpPr>
+          <p:cNvPr id="5" name="Rectangle 4"/>
+          <p:cNvSpPr/>
+          <p:nvPr/>
+        </p:nvSpPr>
+        <p:spPr>
+          <a:xfrm>
+            <a:off x="457200" y="1005840"/>
+            <a:ext cx="1828800" cy="45720"/>
           </a:xfrm>
           <a:prstGeom prst="rect">
             <a:avLst/>
           </a:prstGeom>
           <a:solidFill>
-            <a:srgbClr val="DBEAFE"/>
+            <a:srgbClr val="0066CC"/>
           </a:solidFill>
-          <a:ln w="38100">
-            <a:solidFill>
-              <a:srgbClr val="3B82F6"/>
-            </a:solidFill>
+          <a:ln>
+            <a:noFill/>
           </a:ln>
         </p:spPr>
-        <p:txBody>
-          <a:bodyPr wrap="square" lIns="137160" rIns="137160" tIns="274320" anchor="t">
-            <a:spAutoFit/>
-          </a:bodyPr>
-          <a:lstStyle/>
-          <a:p>
-            <a:pPr algn="ctr">
-              <a:defRPr sz="2800" b="1">
-                <a:solidFill>
-                  <a:srgbClr val="3B82F6"/>
-                </a:solidFill>
-              </a:defRPr>
-            </a:pPr>
-            <a:r>
-              <a:t>Powerful</a:t>
-            </a:r>
-          </a:p>
-          <a:p>
-            <a:pPr algn="ctr">
-              <a:spcBef>
-                <a:spcPts val="1200"/>
-              </a:spcBef>
-              <a:defRPr sz="1600">
-                <a:solidFill>
-                  <a:srgbClr val="1E293B"/>
-                </a:solidFill>
-              </a:defRPr>
-            </a:pPr>
-            <a:r>
-              <a:t>Can build anything from websites to AI</a:t>
-            </a:r>
-          </a:p>
-        </p:txBody>
-      </p:sp>
-      <p:sp>
-        <p:nvSpPr>
-          <p:cNvPr id="5" name="TextBox 4"/>
+        <p:style>
+          <a:lnRef idx="1">
+            <a:schemeClr val="accent1"/>
+          </a:lnRef>
+          <a:fillRef idx="3">
+            <a:schemeClr val="accent1"/>
+          </a:fillRef>
+          <a:effectRef idx="2">
+            <a:schemeClr val="accent1"/>
+          </a:effectRef>
+          <a:fontRef idx="minor">
+            <a:schemeClr val="lt1"/>
+          </a:fontRef>
+        </p:style>
+        <p:txBody>
+          <a:bodyPr rtlCol="0" anchor="ctr"/>
+          <a:lstStyle/>
+          <a:p>
+            <a:pPr algn="ctr"/>
+          </a:p>
+        </p:txBody>
+      </p:sp>
+      <p:sp>
+        <p:nvSpPr>
+          <p:cNvPr id="6" name="TextBox 5"/>
           <p:cNvSpPr txBox="1"/>
           <p:nvPr/>
         </p:nvSpPr>
         <p:spPr>
           <a:xfrm>
-            <a:off x="731520" y="4114800"/>
-            <a:ext cx="3566160" cy="1828800"/>
+            <a:off x="640080" y="1371600"/>
+            <a:ext cx="10789920" cy="4572000"/>
           </a:xfrm>
           <a:prstGeom prst="rect">
             <a:avLst/>
           </a:prstGeom>
-          <a:solidFill>
-            <a:srgbClr val="DBEAFE"/>
-          </a:solidFill>
-          <a:ln w="38100">
-            <a:solidFill>
-              <a:srgbClr val="3B82F6"/>
-            </a:solidFill>
-          </a:ln>
-        </p:spPr>
-        <p:txBody>
-          <a:bodyPr wrap="square" lIns="137160" rIns="137160" tIns="274320" anchor="t">
+          <a:noFill/>
+        </p:spPr>
+        <p:txBody>
+          <a:bodyPr wrap="square">
             <a:spAutoFit/>
           </a:bodyPr>
           <a:lstStyle/>
           <a:p>
-            <a:pPr algn="ctr">
-              <a:defRPr sz="2800" b="1">
-                <a:solidFill>
-                  <a:srgbClr val="3B82F6"/>
+            <a:pPr>
+              <a:spcAft>
+                <a:spcPts val="800"/>
+              </a:spcAft>
+              <a:defRPr sz="2000" b="1">
+                <a:solidFill>
+                  <a:srgbClr val="333333"/>
                 </a:solidFill>
               </a:defRPr>
             </a:pPr>
             <a:r>
+              <a:t>Easy to Learn</a:t>
+            </a:r>
+          </a:p>
+          <a:p>
+            <a:pPr>
+              <a:spcAft>
+                <a:spcPts val="800"/>
+              </a:spcAft>
+              <a:defRPr sz="2000" b="1">
+                <a:solidFill>
+                  <a:srgbClr val="333333"/>
+                </a:solidFill>
+              </a:defRPr>
+            </a:pPr>
+            <a:r>
+              <a:t>Python reads almost like English, making it perfect for beginners</a:t>
+            </a:r>
+          </a:p>
+          <a:p>
+            <a:pPr>
+              <a:spcAft>
+                <a:spcPts val="800"/>
+              </a:spcAft>
+              <a:defRPr sz="2000" b="1">
+                <a:solidFill>
+                  <a:srgbClr val="333333"/>
+                </a:solidFill>
+              </a:defRPr>
+            </a:pPr>
+            <a:r>
+              <a:t>Powerful</a:t>
+            </a:r>
+          </a:p>
+          <a:p>
+            <a:pPr>
+              <a:spcAft>
+                <a:spcPts val="800"/>
+              </a:spcAft>
+              <a:defRPr sz="2000" b="1">
+                <a:solidFill>
+                  <a:srgbClr val="333333"/>
+                </a:solidFill>
+              </a:defRPr>
+            </a:pPr>
+            <a:r>
+              <a:t>Used by Google, Netflix, NASA, and many big companies</a:t>
+            </a:r>
+          </a:p>
+          <a:p>
+            <a:pPr>
+              <a:spcAft>
+                <a:spcPts val="800"/>
+              </a:spcAft>
+              <a:defRPr sz="2000" b="1">
+                <a:solidFill>
+                  <a:srgbClr val="333333"/>
+                </a:solidFill>
+              </a:defRPr>
+            </a:pPr>
+            <a:r>
               <a:t>Versatile</a:t>
             </a:r>
           </a:p>
           <a:p>
-            <a:pPr algn="ctr">
-              <a:spcBef>
-                <a:spcPts val="1200"/>
-              </a:spcBef>
-              <a:defRPr sz="1600">
-                <a:solidFill>
-                  <a:srgbClr val="1E293B"/>
+            <a:pPr>
+              <a:spcAft>
+                <a:spcPts val="800"/>
+              </a:spcAft>
+              <a:defRPr sz="2000" b="1">
+                <a:solidFill>
+                  <a:srgbClr val="333333"/>
                 </a:solidFill>
               </a:defRPr>
             </a:pPr>
             <a:r>
-              <a:t>Used in web, data, science, automation</a:t>
-            </a:r>
-          </a:p>
-        </p:txBody>
-      </p:sp>
-      <p:sp>
-        <p:nvSpPr>
-          <p:cNvPr id="6" name="TextBox 5"/>
-          <p:cNvSpPr txBox="1"/>
-          <p:nvPr/>
-        </p:nvSpPr>
-        <p:spPr>
-          <a:xfrm>
-            <a:off x="4846320" y="4114800"/>
-            <a:ext cx="3566160" cy="1828800"/>
-          </a:xfrm>
-          <a:prstGeom prst="rect">
-            <a:avLst/>
-          </a:prstGeom>
-          <a:solidFill>
-            <a:srgbClr val="DBEAFE"/>
-          </a:solidFill>
-          <a:ln w="38100">
-            <a:solidFill>
-              <a:srgbClr val="3B82F6"/>
-            </a:solidFill>
-          </a:ln>
-        </p:spPr>
-        <p:txBody>
-          <a:bodyPr wrap="square" lIns="137160" rIns="137160" tIns="274320" anchor="t">
-            <a:spAutoFit/>
-          </a:bodyPr>
-          <a:lstStyle/>
-          <a:p>
-            <a:pPr algn="ctr">
-              <a:defRPr sz="2800" b="1">
-                <a:solidFill>
-                  <a:srgbClr val="3B82F6"/>
+              <a:t>Build websites, analyze data, create AI, automate tasks, and more!</a:t>
+            </a:r>
+          </a:p>
+          <a:p>
+            <a:pPr>
+              <a:spcAft>
+                <a:spcPts val="800"/>
+              </a:spcAft>
+              <a:defRPr sz="2000" b="1">
+                <a:solidFill>
+                  <a:srgbClr val="333333"/>
                 </a:solidFill>
               </a:defRPr>
             </a:pPr>
@@ -3841,18 +4015,18 @@
             </a:r>
           </a:p>
           <a:p>
-            <a:pPr algn="ctr">
-              <a:spcBef>
-                <a:spcPts val="1200"/>
-              </a:spcBef>
-              <a:defRPr sz="1600">
-                <a:solidFill>
-                  <a:srgbClr val="1E293B"/>
+            <a:pPr>
+              <a:spcAft>
+                <a:spcPts val="800"/>
+              </a:spcAft>
+              <a:defRPr sz="2000" b="1">
+                <a:solidFill>
+                  <a:srgbClr val="333333"/>
                 </a:solidFill>
               </a:defRPr>
             </a:pPr>
             <a:r>
-              <a:t>Huge community and tons of resources</a:t>
+              <a:t>One of the most in-demand programming languages in the world</a:t>
             </a:r>
           </a:p>
         </p:txBody>
@@ -3868,14 +4042,6 @@
 <file path=ppt/slides/slide4.xml><?xml version="1.0" encoding="utf-8"?>
 <p:sld xmlns:a="http://schemas.openxmlformats.org/drawingml/2006/main" xmlns:p="http://schemas.openxmlformats.org/presentationml/2006/main" xmlns:r="http://schemas.openxmlformats.org/officeDocument/2006/relationships">
   <p:cSld>
-    <p:bg>
-      <p:bgPr>
-        <a:solidFill>
-          <a:srgbClr val="FFFFFF"/>
-        </a:solidFill>
-        <a:effectLst/>
-      </p:bgPr>
-    </p:bg>
     <p:spTree>
       <p:nvGrpSpPr>
         <p:cNvPr id="1" name=""/>
@@ -3885,51 +4051,100 @@
       <p:grpSpPr/>
       <p:sp>
         <p:nvSpPr>
-          <p:cNvPr id="2" name="TextBox 1"/>
-          <p:cNvSpPr txBox="1"/>
+          <p:cNvPr id="2" name="Rectangle 1"/>
+          <p:cNvSpPr/>
           <p:nvPr/>
         </p:nvSpPr>
         <p:spPr>
           <a:xfrm>
             <a:off x="0" y="0"/>
-            <a:ext cx="9144000" cy="1097280"/>
+            <a:ext cx="12191695" cy="6858000"/>
           </a:xfrm>
           <a:prstGeom prst="rect">
             <a:avLst/>
           </a:prstGeom>
           <a:solidFill>
-            <a:srgbClr val="3B82F6"/>
+            <a:srgbClr val="FFFFFF"/>
           </a:solidFill>
-        </p:spPr>
-        <p:txBody>
-          <a:bodyPr wrap="none" tIns="182880">
-            <a:spAutoFit/>
-          </a:bodyPr>
-          <a:lstStyle/>
-          <a:p>
-            <a:pPr algn="ctr">
-              <a:defRPr sz="4400" b="1">
-                <a:solidFill>
-                  <a:srgbClr val="FFFFFF"/>
-                </a:solidFill>
-              </a:defRPr>
-            </a:pPr>
-            <a:r>
-              <a:t>Variables: Storing Information</a:t>
-            </a:r>
-          </a:p>
-        </p:txBody>
-      </p:sp>
-      <p:sp>
-        <p:nvSpPr>
-          <p:cNvPr id="3" name="TextBox 2"/>
+          <a:ln>
+            <a:noFill/>
+          </a:ln>
+        </p:spPr>
+        <p:style>
+          <a:lnRef idx="1">
+            <a:schemeClr val="accent1"/>
+          </a:lnRef>
+          <a:fillRef idx="3">
+            <a:schemeClr val="accent1"/>
+          </a:fillRef>
+          <a:effectRef idx="2">
+            <a:schemeClr val="accent1"/>
+          </a:effectRef>
+          <a:fontRef idx="minor">
+            <a:schemeClr val="lt1"/>
+          </a:fontRef>
+        </p:style>
+        <p:txBody>
+          <a:bodyPr rtlCol="0" anchor="ctr"/>
+          <a:lstStyle/>
+          <a:p>
+            <a:pPr algn="ctr"/>
+          </a:p>
+        </p:txBody>
+      </p:sp>
+      <p:sp>
+        <p:nvSpPr>
+          <p:cNvPr id="3" name="Rectangle 2"/>
+          <p:cNvSpPr/>
+          <p:nvPr/>
+        </p:nvSpPr>
+        <p:spPr>
+          <a:xfrm>
+            <a:off x="0" y="0"/>
+            <a:ext cx="12191695" cy="137160"/>
+          </a:xfrm>
+          <a:prstGeom prst="rect">
+            <a:avLst/>
+          </a:prstGeom>
+          <a:solidFill>
+            <a:srgbClr val="0066CC"/>
+          </a:solidFill>
+          <a:ln>
+            <a:noFill/>
+          </a:ln>
+        </p:spPr>
+        <p:style>
+          <a:lnRef idx="1">
+            <a:schemeClr val="accent1"/>
+          </a:lnRef>
+          <a:fillRef idx="3">
+            <a:schemeClr val="accent1"/>
+          </a:fillRef>
+          <a:effectRef idx="2">
+            <a:schemeClr val="accent1"/>
+          </a:effectRef>
+          <a:fontRef idx="minor">
+            <a:schemeClr val="lt1"/>
+          </a:fontRef>
+        </p:style>
+        <p:txBody>
+          <a:bodyPr rtlCol="0" anchor="ctr"/>
+          <a:lstStyle/>
+          <a:p>
+            <a:pPr algn="ctr"/>
+          </a:p>
+        </p:txBody>
+      </p:sp>
+      <p:sp>
+        <p:nvSpPr>
+          <p:cNvPr id="4" name="TextBox 3"/>
           <p:cNvSpPr txBox="1"/>
           <p:nvPr/>
         </p:nvSpPr>
         <p:spPr>
           <a:xfrm>
-            <a:off x="914400" y="1645920"/>
-            <a:ext cx="7315200" cy="548640"/>
+            <a:off x="457200" y="365760"/>
+            <a:ext cx="10972800" cy="731520"/>
           </a:xfrm>
           <a:prstGeom prst="rect">
             <a:avLst/>
@@ -3942,144 +4157,231 @@
           </a:bodyPr>
           <a:lstStyle/>
           <a:p>
-            <a:pPr algn="ctr">
-              <a:defRPr sz="2200">
-                <a:solidFill>
-                  <a:srgbClr val="1E293B"/>
+            <a:pPr>
+              <a:defRPr sz="4000" b="1">
+                <a:solidFill>
+                  <a:srgbClr val="003366"/>
                 </a:solidFill>
               </a:defRPr>
             </a:pPr>
             <a:r>
-              <a:t>Variables are like labeled boxes that store information</a:t>
-            </a:r>
-          </a:p>
-        </p:txBody>
-      </p:sp>
-      <p:sp>
-        <p:nvSpPr>
-          <p:cNvPr id="4" name="TextBox 3"/>
-          <p:cNvSpPr txBox="1"/>
+              <a:t>Variables: Storing Information 📦</a:t>
+            </a:r>
+          </a:p>
+        </p:txBody>
+      </p:sp>
+      <p:sp>
+        <p:nvSpPr>
+          <p:cNvPr id="5" name="Rectangle 4"/>
+          <p:cNvSpPr/>
           <p:nvPr/>
         </p:nvSpPr>
         <p:spPr>
           <a:xfrm>
-            <a:off x="1828800" y="2560320"/>
-            <a:ext cx="5486400" cy="731520"/>
+            <a:off x="457200" y="1005840"/>
+            <a:ext cx="1828800" cy="45720"/>
           </a:xfrm>
           <a:prstGeom prst="rect">
             <a:avLst/>
           </a:prstGeom>
           <a:solidFill>
-            <a:srgbClr val="DBEAFE"/>
+            <a:srgbClr val="0066CC"/>
           </a:solidFill>
-          <a:ln w="25400">
-            <a:solidFill>
-              <a:srgbClr val="3B82F6"/>
-            </a:solidFill>
+          <a:ln>
+            <a:noFill/>
           </a:ln>
         </p:spPr>
-        <p:txBody>
-          <a:bodyPr wrap="none" anchor="ctr">
-            <a:spAutoFit/>
-          </a:bodyPr>
-          <a:lstStyle/>
-          <a:p>
-            <a:pPr algn="ctr">
-              <a:defRPr sz="2800">
-                <a:solidFill>
-                  <a:srgbClr val="1E293B"/>
-                </a:solidFill>
-                <a:latin typeface="Courier New"/>
-              </a:defRPr>
-            </a:pPr>
-            <a:r>
-              <a:t>name = "Alice"</a:t>
-            </a:r>
-          </a:p>
-        </p:txBody>
-      </p:sp>
-      <p:sp>
-        <p:nvSpPr>
-          <p:cNvPr id="5" name="TextBox 4"/>
+        <p:style>
+          <a:lnRef idx="1">
+            <a:schemeClr val="accent1"/>
+          </a:lnRef>
+          <a:fillRef idx="3">
+            <a:schemeClr val="accent1"/>
+          </a:fillRef>
+          <a:effectRef idx="2">
+            <a:schemeClr val="accent1"/>
+          </a:effectRef>
+          <a:fontRef idx="minor">
+            <a:schemeClr val="lt1"/>
+          </a:fontRef>
+        </p:style>
+        <p:txBody>
+          <a:bodyPr rtlCol="0" anchor="ctr"/>
+          <a:lstStyle/>
+          <a:p>
+            <a:pPr algn="ctr"/>
+          </a:p>
+        </p:txBody>
+      </p:sp>
+      <p:sp>
+        <p:nvSpPr>
+          <p:cNvPr id="6" name="TextBox 5"/>
           <p:cNvSpPr txBox="1"/>
           <p:nvPr/>
         </p:nvSpPr>
         <p:spPr>
           <a:xfrm>
-            <a:off x="1828800" y="3566160"/>
-            <a:ext cx="5486400" cy="731520"/>
+            <a:off x="640080" y="1371600"/>
+            <a:ext cx="10789920" cy="4572000"/>
           </a:xfrm>
           <a:prstGeom prst="rect">
             <a:avLst/>
           </a:prstGeom>
-          <a:solidFill>
-            <a:srgbClr val="DBEAFE"/>
-          </a:solidFill>
-          <a:ln w="25400">
-            <a:solidFill>
-              <a:srgbClr val="3B82F6"/>
-            </a:solidFill>
-          </a:ln>
-        </p:spPr>
-        <p:txBody>
-          <a:bodyPr wrap="none" anchor="ctr">
+          <a:noFill/>
+        </p:spPr>
+        <p:txBody>
+          <a:bodyPr wrap="square">
             <a:spAutoFit/>
           </a:bodyPr>
           <a:lstStyle/>
           <a:p>
-            <a:pPr algn="ctr">
-              <a:defRPr sz="2800">
-                <a:solidFill>
-                  <a:srgbClr val="1E293B"/>
-                </a:solidFill>
-                <a:latin typeface="Courier New"/>
+            <a:pPr>
+              <a:spcAft>
+                <a:spcPts val="800"/>
+              </a:spcAft>
+              <a:defRPr sz="2000" b="1">
+                <a:solidFill>
+                  <a:srgbClr val="333333"/>
+                </a:solidFill>
               </a:defRPr>
             </a:pPr>
             <a:r>
-              <a:t>age = 25</a:t>
-            </a:r>
-          </a:p>
-        </p:txBody>
-      </p:sp>
-      <p:sp>
-        <p:nvSpPr>
-          <p:cNvPr id="6" name="TextBox 5"/>
-          <p:cNvSpPr txBox="1"/>
-          <p:nvPr/>
-        </p:nvSpPr>
-        <p:spPr>
-          <a:xfrm>
-            <a:off x="1828800" y="4572000"/>
-            <a:ext cx="5486400" cy="731520"/>
-          </a:xfrm>
-          <a:prstGeom prst="rect">
-            <a:avLst/>
-          </a:prstGeom>
-          <a:solidFill>
-            <a:srgbClr val="DBEAFE"/>
-          </a:solidFill>
-          <a:ln w="25400">
-            <a:solidFill>
-              <a:srgbClr val="3B82F6"/>
-            </a:solidFill>
-          </a:ln>
-        </p:spPr>
-        <p:txBody>
-          <a:bodyPr wrap="none" anchor="ctr">
-            <a:spAutoFit/>
-          </a:bodyPr>
-          <a:lstStyle/>
-          <a:p>
-            <a:pPr algn="ctr">
-              <a:defRPr sz="2800">
-                <a:solidFill>
-                  <a:srgbClr val="1E293B"/>
-                </a:solidFill>
-                <a:latin typeface="Courier New"/>
+              <a:t>Think of a variable as a labeled box where you can store information</a:t>
+            </a:r>
+          </a:p>
+          <a:p>
+            <a:pPr>
+              <a:spcAft>
+                <a:spcPts val="800"/>
+              </a:spcAft>
+              <a:defRPr sz="2000" b="1">
+                <a:solidFill>
+                  <a:srgbClr val="333333"/>
+                </a:solidFill>
               </a:defRPr>
             </a:pPr>
             <a:r>
-              <a:t>height = 5.6</a:t>
+              <a:t>Example:</a:t>
+            </a:r>
+          </a:p>
+          <a:p>
+            <a:pPr>
+              <a:spcAft>
+                <a:spcPts val="800"/>
+              </a:spcAft>
+              <a:defRPr sz="2000" b="1">
+                <a:solidFill>
+                  <a:srgbClr val="333333"/>
+                </a:solidFill>
+              </a:defRPr>
+            </a:pPr>
+            <a:r>
+              <a:t>Box Label</a:t>
+            </a:r>
+          </a:p>
+          <a:p>
+            <a:pPr>
+              <a:spcAft>
+                <a:spcPts val="800"/>
+              </a:spcAft>
+              <a:defRPr sz="2000" b="1">
+                <a:solidFill>
+                  <a:srgbClr val="333333"/>
+                </a:solidFill>
+              </a:defRPr>
+            </a:pPr>
+            <a:r>
+              <a:t>name</a:t>
+            </a:r>
+          </a:p>
+          <a:p>
+            <a:pPr>
+              <a:spcAft>
+                <a:spcPts val="800"/>
+              </a:spcAft>
+              <a:defRPr sz="2000" b="1">
+                <a:solidFill>
+                  <a:srgbClr val="333333"/>
+                </a:solidFill>
+              </a:defRPr>
+            </a:pPr>
+            <a:r>
+              <a:t>Contains: "Sarah"</a:t>
+            </a:r>
+          </a:p>
+          <a:p>
+            <a:pPr>
+              <a:spcAft>
+                <a:spcPts val="800"/>
+              </a:spcAft>
+              <a:defRPr sz="2000" b="1">
+                <a:solidFill>
+                  <a:srgbClr val="333333"/>
+                </a:solidFill>
+              </a:defRPr>
+            </a:pPr>
+            <a:r>
+              <a:t>Box Label</a:t>
+            </a:r>
+          </a:p>
+          <a:p>
+            <a:pPr>
+              <a:spcAft>
+                <a:spcPts val="800"/>
+              </a:spcAft>
+              <a:defRPr sz="2000" b="1">
+                <a:solidFill>
+                  <a:srgbClr val="333333"/>
+                </a:solidFill>
+              </a:defRPr>
+            </a:pPr>
+            <a:r>
+              <a:t>Contains: 20</a:t>
+            </a:r>
+          </a:p>
+          <a:p>
+            <a:pPr>
+              <a:spcAft>
+                <a:spcPts val="800"/>
+              </a:spcAft>
+              <a:defRPr sz="2000" b="1">
+                <a:solidFill>
+                  <a:srgbClr val="333333"/>
+                </a:solidFill>
+              </a:defRPr>
+            </a:pPr>
+            <a:r>
+              <a:t>Box Label</a:t>
+            </a:r>
+          </a:p>
+          <a:p>
+            <a:pPr>
+              <a:spcAft>
+                <a:spcPts val="800"/>
+              </a:spcAft>
+              <a:defRPr sz="2000" b="1">
+                <a:solidFill>
+                  <a:srgbClr val="333333"/>
+                </a:solidFill>
+              </a:defRPr>
+            </a:pPr>
+            <a:r>
+              <a:t>height</a:t>
+            </a:r>
+          </a:p>
+          <a:p>
+            <a:pPr>
+              <a:spcAft>
+                <a:spcPts val="800"/>
+              </a:spcAft>
+              <a:defRPr sz="2000" b="1">
+                <a:solidFill>
+                  <a:srgbClr val="333333"/>
+                </a:solidFill>
+              </a:defRPr>
+            </a:pPr>
+            <a:r>
+              <a:t>Contains: 1.65</a:t>
             </a:r>
           </a:p>
         </p:txBody>
@@ -4095,14 +4397,6 @@
 <file path=ppt/slides/slide5.xml><?xml version="1.0" encoding="utf-8"?>
 <p:sld xmlns:a="http://schemas.openxmlformats.org/drawingml/2006/main" xmlns:p="http://schemas.openxmlformats.org/presentationml/2006/main" xmlns:r="http://schemas.openxmlformats.org/officeDocument/2006/relationships">
   <p:cSld>
-    <p:bg>
-      <p:bgPr>
-        <a:solidFill>
-          <a:srgbClr val="FFFFFF"/>
-        </a:solidFill>
-        <a:effectLst/>
-      </p:bgPr>
-    </p:bg>
     <p:spTree>
       <p:nvGrpSpPr>
         <p:cNvPr id="1" name=""/>
@@ -4112,104 +4406,87 @@
       <p:grpSpPr/>
       <p:sp>
         <p:nvSpPr>
-          <p:cNvPr id="2" name="TextBox 1"/>
-          <p:cNvSpPr txBox="1"/>
+          <p:cNvPr id="2" name="Rectangle 1"/>
+          <p:cNvSpPr/>
           <p:nvPr/>
         </p:nvSpPr>
         <p:spPr>
           <a:xfrm>
             <a:off x="0" y="0"/>
-            <a:ext cx="9144000" cy="1097280"/>
+            <a:ext cx="12191695" cy="6858000"/>
           </a:xfrm>
           <a:prstGeom prst="rect">
             <a:avLst/>
           </a:prstGeom>
           <a:solidFill>
-            <a:srgbClr val="3B82F6"/>
+            <a:srgbClr val="FFFFFF"/>
           </a:solidFill>
-        </p:spPr>
-        <p:txBody>
-          <a:bodyPr wrap="none" tIns="182880">
-            <a:spAutoFit/>
-          </a:bodyPr>
-          <a:lstStyle/>
-          <a:p>
-            <a:pPr algn="ctr">
-              <a:defRPr sz="4400" b="1">
-                <a:solidFill>
-                  <a:srgbClr val="FFFFFF"/>
-                </a:solidFill>
-              </a:defRPr>
-            </a:pPr>
-            <a:r>
-              <a:t>Data Types: Numbers</a:t>
-            </a:r>
-          </a:p>
-        </p:txBody>
-      </p:sp>
-      <p:sp>
-        <p:nvSpPr>
-          <p:cNvPr id="3" name="TextBox 2"/>
-          <p:cNvSpPr txBox="1"/>
+          <a:ln>
+            <a:noFill/>
+          </a:ln>
+        </p:spPr>
+        <p:style>
+          <a:lnRef idx="1">
+            <a:schemeClr val="accent1"/>
+          </a:lnRef>
+          <a:fillRef idx="3">
+            <a:schemeClr val="accent1"/>
+          </a:fillRef>
+          <a:effectRef idx="2">
+            <a:schemeClr val="accent1"/>
+          </a:effectRef>
+          <a:fontRef idx="minor">
+            <a:schemeClr val="lt1"/>
+          </a:fontRef>
+        </p:style>
+        <p:txBody>
+          <a:bodyPr rtlCol="0" anchor="ctr"/>
+          <a:lstStyle/>
+          <a:p>
+            <a:pPr algn="ctr"/>
+          </a:p>
+        </p:txBody>
+      </p:sp>
+      <p:sp>
+        <p:nvSpPr>
+          <p:cNvPr id="3" name="Rectangle 2"/>
+          <p:cNvSpPr/>
           <p:nvPr/>
         </p:nvSpPr>
         <p:spPr>
           <a:xfrm>
-            <a:off x="914400" y="1828800"/>
-            <a:ext cx="7315200" cy="2011680"/>
+            <a:off x="0" y="0"/>
+            <a:ext cx="12191695" cy="137160"/>
           </a:xfrm>
           <a:prstGeom prst="rect">
             <a:avLst/>
           </a:prstGeom>
           <a:solidFill>
-            <a:srgbClr val="DBEAFE"/>
+            <a:srgbClr val="0066CC"/>
           </a:solidFill>
-          <a:ln w="25400">
-            <a:solidFill>
-              <a:srgbClr val="3B82F6"/>
-            </a:solidFill>
+          <a:ln>
+            <a:noFill/>
           </a:ln>
         </p:spPr>
-        <p:txBody>
-          <a:bodyPr wrap="none" lIns="274320" tIns="182880">
-            <a:spAutoFit/>
-          </a:bodyPr>
-          <a:lstStyle/>
-          <a:p>
-            <a:pPr>
-              <a:defRPr sz="2800" b="1">
-                <a:solidFill>
-                  <a:srgbClr val="3B82F6"/>
-                </a:solidFill>
-              </a:defRPr>
-            </a:pPr>
-            <a:r>
-              <a:t>Integers (Whole Numbers)</a:t>
-            </a:r>
-          </a:p>
-          <a:p>
-            <a:pPr>
-              <a:spcBef>
-                <a:spcPts val="1200"/>
-              </a:spcBef>
-              <a:defRPr sz="2400">
-                <a:solidFill>
-                  <a:srgbClr val="1E293B"/>
-                </a:solidFill>
-                <a:latin typeface="Courier New"/>
-              </a:defRPr>
-            </a:pPr>
-            <a:r>
-              <a:t>count = 42</a:t>
-            </a:r>
-            <a:br/>
-            <a:r>
-              <a:t>score = 100</a:t>
-            </a:r>
-            <a:br/>
-            <a:r>
-              <a:t>year = 2024</a:t>
-            </a:r>
+        <p:style>
+          <a:lnRef idx="1">
+            <a:schemeClr val="accent1"/>
+          </a:lnRef>
+          <a:fillRef idx="3">
+            <a:schemeClr val="accent1"/>
+          </a:fillRef>
+          <a:effectRef idx="2">
+            <a:schemeClr val="accent1"/>
+          </a:effectRef>
+          <a:fontRef idx="minor">
+            <a:schemeClr val="lt1"/>
+          </a:fontRef>
+        </p:style>
+        <p:txBody>
+          <a:bodyPr rtlCol="0" anchor="ctr"/>
+          <a:lstStyle/>
+          <a:p>
+            <a:pPr algn="ctr"/>
           </a:p>
         </p:txBody>
       </p:sp>
@@ -4221,60 +4498,155 @@
         </p:nvSpPr>
         <p:spPr>
           <a:xfrm>
-            <a:off x="914400" y="4114800"/>
-            <a:ext cx="7315200" cy="2011680"/>
+            <a:off x="457200" y="365760"/>
+            <a:ext cx="10972800" cy="731520"/>
+          </a:xfrm>
+          <a:prstGeom prst="rect">
+            <a:avLst/>
+          </a:prstGeom>
+          <a:noFill/>
+        </p:spPr>
+        <p:txBody>
+          <a:bodyPr wrap="none">
+            <a:spAutoFit/>
+          </a:bodyPr>
+          <a:lstStyle/>
+          <a:p>
+            <a:pPr>
+              <a:defRPr sz="4000" b="1">
+                <a:solidFill>
+                  <a:srgbClr val="003366"/>
+                </a:solidFill>
+              </a:defRPr>
+            </a:pPr>
+            <a:r>
+              <a:t>Data Types: Numbers 🔢</a:t>
+            </a:r>
+          </a:p>
+        </p:txBody>
+      </p:sp>
+      <p:sp>
+        <p:nvSpPr>
+          <p:cNvPr id="5" name="Rectangle 4"/>
+          <p:cNvSpPr/>
+          <p:nvPr/>
+        </p:nvSpPr>
+        <p:spPr>
+          <a:xfrm>
+            <a:off x="457200" y="1005840"/>
+            <a:ext cx="1828800" cy="45720"/>
           </a:xfrm>
           <a:prstGeom prst="rect">
             <a:avLst/>
           </a:prstGeom>
           <a:solidFill>
-            <a:srgbClr val="DBEAFE"/>
+            <a:srgbClr val="0066CC"/>
           </a:solidFill>
-          <a:ln w="25400">
-            <a:solidFill>
-              <a:srgbClr val="3B82F6"/>
-            </a:solidFill>
+          <a:ln>
+            <a:noFill/>
           </a:ln>
         </p:spPr>
-        <p:txBody>
-          <a:bodyPr wrap="none" lIns="274320" tIns="182880">
+        <p:style>
+          <a:lnRef idx="1">
+            <a:schemeClr val="accent1"/>
+          </a:lnRef>
+          <a:fillRef idx="3">
+            <a:schemeClr val="accent1"/>
+          </a:fillRef>
+          <a:effectRef idx="2">
+            <a:schemeClr val="accent1"/>
+          </a:effectRef>
+          <a:fontRef idx="minor">
+            <a:schemeClr val="lt1"/>
+          </a:fontRef>
+        </p:style>
+        <p:txBody>
+          <a:bodyPr rtlCol="0" anchor="ctr"/>
+          <a:lstStyle/>
+          <a:p>
+            <a:pPr algn="ctr"/>
+          </a:p>
+        </p:txBody>
+      </p:sp>
+      <p:sp>
+        <p:nvSpPr>
+          <p:cNvPr id="6" name="TextBox 5"/>
+          <p:cNvSpPr txBox="1"/>
+          <p:nvPr/>
+        </p:nvSpPr>
+        <p:spPr>
+          <a:xfrm>
+            <a:off x="640080" y="1371600"/>
+            <a:ext cx="10789920" cy="4572000"/>
+          </a:xfrm>
+          <a:prstGeom prst="rect">
+            <a:avLst/>
+          </a:prstGeom>
+          <a:noFill/>
+        </p:spPr>
+        <p:txBody>
+          <a:bodyPr wrap="square">
             <a:spAutoFit/>
           </a:bodyPr>
           <a:lstStyle/>
           <a:p>
             <a:pPr>
-              <a:defRPr sz="2800" b="1">
-                <a:solidFill>
-                  <a:srgbClr val="3B82F6"/>
+              <a:spcAft>
+                <a:spcPts val="800"/>
+              </a:spcAft>
+              <a:defRPr sz="2000" b="1">
+                <a:solidFill>
+                  <a:srgbClr val="333333"/>
                 </a:solidFill>
               </a:defRPr>
             </a:pPr>
             <a:r>
-              <a:t>Floats (Decimal Numbers)</a:t>
+              <a:t>Integers (int)</a:t>
             </a:r>
           </a:p>
           <a:p>
             <a:pPr>
-              <a:spcBef>
-                <a:spcPts val="1200"/>
-              </a:spcBef>
-              <a:defRPr sz="2400">
-                <a:solidFill>
-                  <a:srgbClr val="1E293B"/>
-                </a:solidFill>
-                <a:latin typeface="Courier New"/>
+              <a:spcAft>
+                <a:spcPts val="800"/>
+              </a:spcAft>
+              <a:defRPr sz="2000" b="1">
+                <a:solidFill>
+                  <a:srgbClr val="333333"/>
+                </a:solidFill>
               </a:defRPr>
             </a:pPr>
             <a:r>
-              <a:t>price = 19.99</a:t>
-            </a:r>
-            <a:br/>
-            <a:r>
-              <a:t>temperature = 98.6</a:t>
-            </a:r>
-            <a:br/>
-            <a:r>
-              <a:t>pi = 3.14159</a:t>
+              <a:t>Whole numbers without decimals</a:t>
+            </a:r>
+          </a:p>
+          <a:p>
+            <a:pPr>
+              <a:spcAft>
+                <a:spcPts val="800"/>
+              </a:spcAft>
+              <a:defRPr sz="2000" b="1">
+                <a:solidFill>
+                  <a:srgbClr val="333333"/>
+                </a:solidFill>
+              </a:defRPr>
+            </a:pPr>
+            <a:r>
+              <a:t>Floats (float)</a:t>
+            </a:r>
+          </a:p>
+          <a:p>
+            <a:pPr>
+              <a:spcAft>
+                <a:spcPts val="800"/>
+              </a:spcAft>
+              <a:defRPr sz="2000" b="1">
+                <a:solidFill>
+                  <a:srgbClr val="333333"/>
+                </a:solidFill>
+              </a:defRPr>
+            </a:pPr>
+            <a:r>
+              <a:t>Numbers with decimal points</a:t>
             </a:r>
           </a:p>
         </p:txBody>
@@ -4290,14 +4662,6 @@
 <file path=ppt/slides/slide6.xml><?xml version="1.0" encoding="utf-8"?>
 <p:sld xmlns:a="http://schemas.openxmlformats.org/drawingml/2006/main" xmlns:p="http://schemas.openxmlformats.org/presentationml/2006/main" xmlns:r="http://schemas.openxmlformats.org/officeDocument/2006/relationships">
   <p:cSld>
-    <p:bg>
-      <p:bgPr>
-        <a:solidFill>
-          <a:srgbClr val="FFFFFF"/>
-        </a:solidFill>
-        <a:effectLst/>
-      </p:bgPr>
-    </p:bg>
     <p:spTree>
       <p:nvGrpSpPr>
         <p:cNvPr id="1" name=""/>
@@ -4307,51 +4671,100 @@
       <p:grpSpPr/>
       <p:sp>
         <p:nvSpPr>
-          <p:cNvPr id="2" name="TextBox 1"/>
-          <p:cNvSpPr txBox="1"/>
+          <p:cNvPr id="2" name="Rectangle 1"/>
+          <p:cNvSpPr/>
           <p:nvPr/>
         </p:nvSpPr>
         <p:spPr>
           <a:xfrm>
             <a:off x="0" y="0"/>
-            <a:ext cx="9144000" cy="1097280"/>
+            <a:ext cx="12191695" cy="6858000"/>
           </a:xfrm>
           <a:prstGeom prst="rect">
             <a:avLst/>
           </a:prstGeom>
           <a:solidFill>
-            <a:srgbClr val="3B82F6"/>
+            <a:srgbClr val="FFFFFF"/>
           </a:solidFill>
-        </p:spPr>
-        <p:txBody>
-          <a:bodyPr wrap="none" tIns="182880">
-            <a:spAutoFit/>
-          </a:bodyPr>
-          <a:lstStyle/>
-          <a:p>
-            <a:pPr algn="ctr">
-              <a:defRPr sz="4400" b="1">
-                <a:solidFill>
-                  <a:srgbClr val="FFFFFF"/>
-                </a:solidFill>
-              </a:defRPr>
-            </a:pPr>
-            <a:r>
-              <a:t>Data Types: Text (Strings)</a:t>
-            </a:r>
-          </a:p>
-        </p:txBody>
-      </p:sp>
-      <p:sp>
-        <p:nvSpPr>
-          <p:cNvPr id="3" name="TextBox 2"/>
+          <a:ln>
+            <a:noFill/>
+          </a:ln>
+        </p:spPr>
+        <p:style>
+          <a:lnRef idx="1">
+            <a:schemeClr val="accent1"/>
+          </a:lnRef>
+          <a:fillRef idx="3">
+            <a:schemeClr val="accent1"/>
+          </a:fillRef>
+          <a:effectRef idx="2">
+            <a:schemeClr val="accent1"/>
+          </a:effectRef>
+          <a:fontRef idx="minor">
+            <a:schemeClr val="lt1"/>
+          </a:fontRef>
+        </p:style>
+        <p:txBody>
+          <a:bodyPr rtlCol="0" anchor="ctr"/>
+          <a:lstStyle/>
+          <a:p>
+            <a:pPr algn="ctr"/>
+          </a:p>
+        </p:txBody>
+      </p:sp>
+      <p:sp>
+        <p:nvSpPr>
+          <p:cNvPr id="3" name="Rectangle 2"/>
+          <p:cNvSpPr/>
+          <p:nvPr/>
+        </p:nvSpPr>
+        <p:spPr>
+          <a:xfrm>
+            <a:off x="0" y="0"/>
+            <a:ext cx="12191695" cy="137160"/>
+          </a:xfrm>
+          <a:prstGeom prst="rect">
+            <a:avLst/>
+          </a:prstGeom>
+          <a:solidFill>
+            <a:srgbClr val="0066CC"/>
+          </a:solidFill>
+          <a:ln>
+            <a:noFill/>
+          </a:ln>
+        </p:spPr>
+        <p:style>
+          <a:lnRef idx="1">
+            <a:schemeClr val="accent1"/>
+          </a:lnRef>
+          <a:fillRef idx="3">
+            <a:schemeClr val="accent1"/>
+          </a:fillRef>
+          <a:effectRef idx="2">
+            <a:schemeClr val="accent1"/>
+          </a:effectRef>
+          <a:fontRef idx="minor">
+            <a:schemeClr val="lt1"/>
+          </a:fontRef>
+        </p:style>
+        <p:txBody>
+          <a:bodyPr rtlCol="0" anchor="ctr"/>
+          <a:lstStyle/>
+          <a:p>
+            <a:pPr algn="ctr"/>
+          </a:p>
+        </p:txBody>
+      </p:sp>
+      <p:sp>
+        <p:nvSpPr>
+          <p:cNvPr id="4" name="TextBox 3"/>
           <p:cNvSpPr txBox="1"/>
           <p:nvPr/>
         </p:nvSpPr>
         <p:spPr>
           <a:xfrm>
-            <a:off x="914400" y="1645920"/>
-            <a:ext cx="7315200" cy="548640"/>
+            <a:off x="457200" y="365760"/>
+            <a:ext cx="10972800" cy="731520"/>
           </a:xfrm>
           <a:prstGeom prst="rect">
             <a:avLst/>
@@ -4364,189 +4777,141 @@
           </a:bodyPr>
           <a:lstStyle/>
           <a:p>
-            <a:pPr algn="ctr">
-              <a:defRPr sz="2200">
-                <a:solidFill>
-                  <a:srgbClr val="1E293B"/>
+            <a:pPr>
+              <a:defRPr sz="4000" b="1">
+                <a:solidFill>
+                  <a:srgbClr val="003366"/>
                 </a:solidFill>
               </a:defRPr>
             </a:pPr>
             <a:r>
-              <a:t>Strings are text wrapped in quotes (single or double)</a:t>
-            </a:r>
-          </a:p>
-        </p:txBody>
-      </p:sp>
-      <p:sp>
-        <p:nvSpPr>
-          <p:cNvPr id="4" name="TextBox 3"/>
-          <p:cNvSpPr txBox="1"/>
+              <a:t>Data Types: Text (Strings) 📝</a:t>
+            </a:r>
+          </a:p>
+        </p:txBody>
+      </p:sp>
+      <p:sp>
+        <p:nvSpPr>
+          <p:cNvPr id="5" name="Rectangle 4"/>
+          <p:cNvSpPr/>
           <p:nvPr/>
         </p:nvSpPr>
         <p:spPr>
           <a:xfrm>
-            <a:off x="1371600" y="2560320"/>
-            <a:ext cx="6400800" cy="914400"/>
+            <a:off x="457200" y="1005840"/>
+            <a:ext cx="1828800" cy="45720"/>
           </a:xfrm>
           <a:prstGeom prst="rect">
             <a:avLst/>
           </a:prstGeom>
           <a:solidFill>
-            <a:srgbClr val="DBEAFE"/>
+            <a:srgbClr val="0066CC"/>
           </a:solidFill>
-          <a:ln w="25400">
-            <a:solidFill>
-              <a:srgbClr val="3B82F6"/>
-            </a:solidFill>
+          <a:ln>
+            <a:noFill/>
           </a:ln>
         </p:spPr>
-        <p:txBody>
-          <a:bodyPr wrap="none" lIns="182880" tIns="137160">
-            <a:spAutoFit/>
-          </a:bodyPr>
-          <a:lstStyle/>
-          <a:p>
-            <a:pPr>
-              <a:defRPr sz="1800" b="1">
-                <a:solidFill>
-                  <a:srgbClr val="3B82F6"/>
-                </a:solidFill>
-              </a:defRPr>
-            </a:pPr>
-            <a:r>
-              <a:t>Single Quotes</a:t>
-            </a:r>
-          </a:p>
-          <a:p>
-            <a:pPr>
-              <a:spcBef>
-                <a:spcPts val="600"/>
-              </a:spcBef>
-              <a:defRPr sz="2200">
-                <a:solidFill>
-                  <a:srgbClr val="1E293B"/>
-                </a:solidFill>
-                <a:latin typeface="Courier New"/>
-              </a:defRPr>
-            </a:pPr>
-            <a:r>
-              <a:t>message = 'Hello, World!'</a:t>
-            </a:r>
-          </a:p>
-        </p:txBody>
-      </p:sp>
-      <p:sp>
-        <p:nvSpPr>
-          <p:cNvPr id="5" name="TextBox 4"/>
+        <p:style>
+          <a:lnRef idx="1">
+            <a:schemeClr val="accent1"/>
+          </a:lnRef>
+          <a:fillRef idx="3">
+            <a:schemeClr val="accent1"/>
+          </a:fillRef>
+          <a:effectRef idx="2">
+            <a:schemeClr val="accent1"/>
+          </a:effectRef>
+          <a:fontRef idx="minor">
+            <a:schemeClr val="lt1"/>
+          </a:fontRef>
+        </p:style>
+        <p:txBody>
+          <a:bodyPr rtlCol="0" anchor="ctr"/>
+          <a:lstStyle/>
+          <a:p>
+            <a:pPr algn="ctr"/>
+          </a:p>
+        </p:txBody>
+      </p:sp>
+      <p:sp>
+        <p:nvSpPr>
+          <p:cNvPr id="6" name="TextBox 5"/>
           <p:cNvSpPr txBox="1"/>
           <p:nvPr/>
         </p:nvSpPr>
         <p:spPr>
           <a:xfrm>
-            <a:off x="1371600" y="3749039"/>
-            <a:ext cx="6400800" cy="914400"/>
+            <a:off x="640080" y="1371600"/>
+            <a:ext cx="10789920" cy="4572000"/>
           </a:xfrm>
           <a:prstGeom prst="rect">
             <a:avLst/>
           </a:prstGeom>
-          <a:solidFill>
-            <a:srgbClr val="DBEAFE"/>
-          </a:solidFill>
-          <a:ln w="25400">
-            <a:solidFill>
-              <a:srgbClr val="3B82F6"/>
-            </a:solidFill>
-          </a:ln>
-        </p:spPr>
-        <p:txBody>
-          <a:bodyPr wrap="none" lIns="182880" tIns="137160">
+          <a:noFill/>
+        </p:spPr>
+        <p:txBody>
+          <a:bodyPr wrap="square">
             <a:spAutoFit/>
           </a:bodyPr>
           <a:lstStyle/>
           <a:p>
             <a:pPr>
-              <a:defRPr sz="1800" b="1">
-                <a:solidFill>
-                  <a:srgbClr val="3B82F6"/>
+              <a:spcAft>
+                <a:spcPts val="800"/>
+              </a:spcAft>
+              <a:defRPr sz="2000" b="1">
+                <a:solidFill>
+                  <a:srgbClr val="333333"/>
                 </a:solidFill>
               </a:defRPr>
             </a:pPr>
             <a:r>
-              <a:t>Double Quotes</a:t>
+              <a:t>Strings are text enclosed in quotes - single or double</a:t>
             </a:r>
           </a:p>
           <a:p>
             <a:pPr>
-              <a:spcBef>
-                <a:spcPts val="600"/>
-              </a:spcBef>
-              <a:defRPr sz="2200">
-                <a:solidFill>
-                  <a:srgbClr val="1E293B"/>
-                </a:solidFill>
-                <a:latin typeface="Courier New"/>
+              <a:spcAft>
+                <a:spcPts val="800"/>
+              </a:spcAft>
+              <a:defRPr sz="2000" b="1">
+                <a:solidFill>
+                  <a:srgbClr val="333333"/>
+                </a:solidFill>
               </a:defRPr>
             </a:pPr>
             <a:r>
-              <a:t>greeting = "Welcome to Python"</a:t>
-            </a:r>
-          </a:p>
-        </p:txBody>
-      </p:sp>
-      <p:sp>
-        <p:nvSpPr>
-          <p:cNvPr id="6" name="TextBox 5"/>
-          <p:cNvSpPr txBox="1"/>
-          <p:nvPr/>
-        </p:nvSpPr>
-        <p:spPr>
-          <a:xfrm>
-            <a:off x="1371600" y="4937759"/>
-            <a:ext cx="6400800" cy="914400"/>
-          </a:xfrm>
-          <a:prstGeom prst="rect">
-            <a:avLst/>
-          </a:prstGeom>
-          <a:solidFill>
-            <a:srgbClr val="DBEAFE"/>
-          </a:solidFill>
-          <a:ln w="25400">
-            <a:solidFill>
-              <a:srgbClr val="3B82F6"/>
-            </a:solidFill>
-          </a:ln>
-        </p:spPr>
-        <p:txBody>
-          <a:bodyPr wrap="none" lIns="182880" tIns="137160">
-            <a:spAutoFit/>
-          </a:bodyPr>
-          <a:lstStyle/>
+              <a:t>Important:Both 'single' and "double" quotes work, but be consistent!</a:t>
+            </a:r>
+          </a:p>
           <a:p>
             <a:pPr>
-              <a:defRPr sz="1800" b="1">
-                <a:solidFill>
-                  <a:srgbClr val="3B82F6"/>
+              <a:spcAft>
+                <a:spcPts val="800"/>
+              </a:spcAft>
+              <a:defRPr sz="2000" b="1">
+                <a:solidFill>
+                  <a:srgbClr val="333333"/>
                 </a:solidFill>
               </a:defRPr>
             </a:pPr>
             <a:r>
-              <a:t>Multi-word Text</a:t>
+              <a:t>✓ Correct</a:t>
             </a:r>
           </a:p>
           <a:p>
             <a:pPr>
-              <a:spcBef>
-                <a:spcPts val="600"/>
-              </a:spcBef>
-              <a:defRPr sz="2200">
-                <a:solidFill>
-                  <a:srgbClr val="1E293B"/>
-                </a:solidFill>
-                <a:latin typeface="Courier New"/>
+              <a:spcAft>
+                <a:spcPts val="800"/>
+              </a:spcAft>
+              <a:defRPr sz="2000" b="1">
+                <a:solidFill>
+                  <a:srgbClr val="333333"/>
+                </a:solidFill>
               </a:defRPr>
             </a:pPr>
             <a:r>
-              <a:t>sentence = "Learning Python is fun!"</a:t>
+              <a:t>✗ Wrong</a:t>
             </a:r>
           </a:p>
         </p:txBody>
@@ -4562,14 +4927,6 @@
 <file path=ppt/slides/slide7.xml><?xml version="1.0" encoding="utf-8"?>
 <p:sld xmlns:a="http://schemas.openxmlformats.org/drawingml/2006/main" xmlns:p="http://schemas.openxmlformats.org/presentationml/2006/main" xmlns:r="http://schemas.openxmlformats.org/officeDocument/2006/relationships">
   <p:cSld>
-    <p:bg>
-      <p:bgPr>
-        <a:solidFill>
-          <a:srgbClr val="FFFFFF"/>
-        </a:solidFill>
-        <a:effectLst/>
-      </p:bgPr>
-    </p:bg>
     <p:spTree>
       <p:nvGrpSpPr>
         <p:cNvPr id="1" name=""/>
@@ -4579,96 +4936,87 @@
       <p:grpSpPr/>
       <p:sp>
         <p:nvSpPr>
-          <p:cNvPr id="2" name="TextBox 1"/>
-          <p:cNvSpPr txBox="1"/>
+          <p:cNvPr id="2" name="Rectangle 1"/>
+          <p:cNvSpPr/>
           <p:nvPr/>
         </p:nvSpPr>
         <p:spPr>
           <a:xfrm>
             <a:off x="0" y="0"/>
-            <a:ext cx="9144000" cy="1097280"/>
+            <a:ext cx="12191695" cy="6858000"/>
           </a:xfrm>
           <a:prstGeom prst="rect">
             <a:avLst/>
           </a:prstGeom>
           <a:solidFill>
-            <a:srgbClr val="3B82F6"/>
+            <a:srgbClr val="FFFFFF"/>
           </a:solidFill>
-        </p:spPr>
-        <p:txBody>
-          <a:bodyPr wrap="none" tIns="182880">
-            <a:spAutoFit/>
-          </a:bodyPr>
-          <a:lstStyle/>
-          <a:p>
-            <a:pPr algn="ctr">
-              <a:defRPr sz="4400" b="1">
-                <a:solidFill>
-                  <a:srgbClr val="FFFFFF"/>
-                </a:solidFill>
-              </a:defRPr>
-            </a:pPr>
-            <a:r>
-              <a:t>Math Operations</a:t>
-            </a:r>
-          </a:p>
-        </p:txBody>
-      </p:sp>
-      <p:sp>
-        <p:nvSpPr>
-          <p:cNvPr id="3" name="TextBox 2"/>
-          <p:cNvSpPr txBox="1"/>
+          <a:ln>
+            <a:noFill/>
+          </a:ln>
+        </p:spPr>
+        <p:style>
+          <a:lnRef idx="1">
+            <a:schemeClr val="accent1"/>
+          </a:lnRef>
+          <a:fillRef idx="3">
+            <a:schemeClr val="accent1"/>
+          </a:fillRef>
+          <a:effectRef idx="2">
+            <a:schemeClr val="accent1"/>
+          </a:effectRef>
+          <a:fontRef idx="minor">
+            <a:schemeClr val="lt1"/>
+          </a:fontRef>
+        </p:style>
+        <p:txBody>
+          <a:bodyPr rtlCol="0" anchor="ctr"/>
+          <a:lstStyle/>
+          <a:p>
+            <a:pPr algn="ctr"/>
+          </a:p>
+        </p:txBody>
+      </p:sp>
+      <p:sp>
+        <p:nvSpPr>
+          <p:cNvPr id="3" name="Rectangle 2"/>
+          <p:cNvSpPr/>
           <p:nvPr/>
         </p:nvSpPr>
         <p:spPr>
           <a:xfrm>
-            <a:off x="457200" y="1828800"/>
-            <a:ext cx="4114800" cy="1005840"/>
+            <a:off x="0" y="0"/>
+            <a:ext cx="12191695" cy="137160"/>
           </a:xfrm>
           <a:prstGeom prst="rect">
             <a:avLst/>
           </a:prstGeom>
           <a:solidFill>
-            <a:srgbClr val="DBEAFE"/>
+            <a:srgbClr val="0066CC"/>
           </a:solidFill>
-          <a:ln w="25400">
-            <a:solidFill>
-              <a:srgbClr val="3B82F6"/>
-            </a:solidFill>
+          <a:ln>
+            <a:noFill/>
           </a:ln>
         </p:spPr>
-        <p:txBody>
-          <a:bodyPr wrap="none" lIns="182880" tIns="137160">
-            <a:spAutoFit/>
-          </a:bodyPr>
-          <a:lstStyle/>
-          <a:p>
-            <a:pPr>
-              <a:defRPr sz="2000" b="1">
-                <a:solidFill>
-                  <a:srgbClr val="3B82F6"/>
-                </a:solidFill>
-              </a:defRPr>
-            </a:pPr>
-            <a:r>
-              <a:t>Addition</a:t>
-            </a:r>
-          </a:p>
-          <a:p>
-            <a:pPr>
-              <a:spcBef>
-                <a:spcPts val="600"/>
-              </a:spcBef>
-              <a:defRPr sz="2200">
-                <a:solidFill>
-                  <a:srgbClr val="1E293B"/>
-                </a:solidFill>
-                <a:latin typeface="Courier New"/>
-              </a:defRPr>
-            </a:pPr>
-            <a:r>
-              <a:t>10 + 5  # 15</a:t>
-            </a:r>
+        <p:style>
+          <a:lnRef idx="1">
+            <a:schemeClr val="accent1"/>
+          </a:lnRef>
+          <a:fillRef idx="3">
+            <a:schemeClr val="accent1"/>
+          </a:fillRef>
+          <a:effectRef idx="2">
+            <a:schemeClr val="accent1"/>
+          </a:effectRef>
+          <a:fontRef idx="minor">
+            <a:schemeClr val="lt1"/>
+          </a:fontRef>
+        </p:style>
+        <p:txBody>
+          <a:bodyPr rtlCol="0" anchor="ctr"/>
+          <a:lstStyle/>
+          <a:p>
+            <a:pPr algn="ctr"/>
           </a:p>
         </p:txBody>
       </p:sp>
@@ -4680,284 +5028,185 @@
         </p:nvSpPr>
         <p:spPr>
           <a:xfrm>
-            <a:off x="457200" y="3200400"/>
-            <a:ext cx="4114800" cy="1005840"/>
+            <a:off x="457200" y="365760"/>
+            <a:ext cx="10972800" cy="731520"/>
+          </a:xfrm>
+          <a:prstGeom prst="rect">
+            <a:avLst/>
+          </a:prstGeom>
+          <a:noFill/>
+        </p:spPr>
+        <p:txBody>
+          <a:bodyPr wrap="none">
+            <a:spAutoFit/>
+          </a:bodyPr>
+          <a:lstStyle/>
+          <a:p>
+            <a:pPr>
+              <a:defRPr sz="4000" b="1">
+                <a:solidFill>
+                  <a:srgbClr val="003366"/>
+                </a:solidFill>
+              </a:defRPr>
+            </a:pPr>
+            <a:r>
+              <a:t>Math Operations ➕➖✖️➗</a:t>
+            </a:r>
+          </a:p>
+        </p:txBody>
+      </p:sp>
+      <p:sp>
+        <p:nvSpPr>
+          <p:cNvPr id="5" name="Rectangle 4"/>
+          <p:cNvSpPr/>
+          <p:nvPr/>
+        </p:nvSpPr>
+        <p:spPr>
+          <a:xfrm>
+            <a:off x="457200" y="1005840"/>
+            <a:ext cx="1828800" cy="45720"/>
           </a:xfrm>
           <a:prstGeom prst="rect">
             <a:avLst/>
           </a:prstGeom>
           <a:solidFill>
-            <a:srgbClr val="DBEAFE"/>
+            <a:srgbClr val="0066CC"/>
           </a:solidFill>
-          <a:ln w="25400">
-            <a:solidFill>
-              <a:srgbClr val="3B82F6"/>
-            </a:solidFill>
+          <a:ln>
+            <a:noFill/>
           </a:ln>
         </p:spPr>
-        <p:txBody>
-          <a:bodyPr wrap="none" lIns="182880" tIns="137160">
-            <a:spAutoFit/>
-          </a:bodyPr>
-          <a:lstStyle/>
-          <a:p>
-            <a:pPr>
-              <a:defRPr sz="2000" b="1">
-                <a:solidFill>
-                  <a:srgbClr val="3B82F6"/>
-                </a:solidFill>
-              </a:defRPr>
-            </a:pPr>
-            <a:r>
-              <a:t>Subtraction</a:t>
-            </a:r>
-          </a:p>
-          <a:p>
-            <a:pPr>
-              <a:spcBef>
-                <a:spcPts val="600"/>
-              </a:spcBef>
-              <a:defRPr sz="2200">
-                <a:solidFill>
-                  <a:srgbClr val="1E293B"/>
-                </a:solidFill>
-                <a:latin typeface="Courier New"/>
-              </a:defRPr>
-            </a:pPr>
-            <a:r>
-              <a:t>10 - 5  # 5</a:t>
-            </a:r>
-          </a:p>
-        </p:txBody>
-      </p:sp>
-      <p:sp>
-        <p:nvSpPr>
-          <p:cNvPr id="5" name="TextBox 4"/>
+        <p:style>
+          <a:lnRef idx="1">
+            <a:schemeClr val="accent1"/>
+          </a:lnRef>
+          <a:fillRef idx="3">
+            <a:schemeClr val="accent1"/>
+          </a:fillRef>
+          <a:effectRef idx="2">
+            <a:schemeClr val="accent1"/>
+          </a:effectRef>
+          <a:fontRef idx="minor">
+            <a:schemeClr val="lt1"/>
+          </a:fontRef>
+        </p:style>
+        <p:txBody>
+          <a:bodyPr rtlCol="0" anchor="ctr"/>
+          <a:lstStyle/>
+          <a:p>
+            <a:pPr algn="ctr"/>
+          </a:p>
+        </p:txBody>
+      </p:sp>
+      <p:sp>
+        <p:nvSpPr>
+          <p:cNvPr id="6" name="TextBox 5"/>
           <p:cNvSpPr txBox="1"/>
           <p:nvPr/>
         </p:nvSpPr>
         <p:spPr>
           <a:xfrm>
-            <a:off x="457200" y="4572000"/>
-            <a:ext cx="4114800" cy="1005840"/>
+            <a:off x="640080" y="1371600"/>
+            <a:ext cx="10789920" cy="4572000"/>
           </a:xfrm>
           <a:prstGeom prst="rect">
             <a:avLst/>
           </a:prstGeom>
-          <a:solidFill>
-            <a:srgbClr val="DBEAFE"/>
-          </a:solidFill>
-          <a:ln w="25400">
-            <a:solidFill>
-              <a:srgbClr val="3B82F6"/>
-            </a:solidFill>
-          </a:ln>
-        </p:spPr>
-        <p:txBody>
-          <a:bodyPr wrap="none" lIns="182880" tIns="137160">
+          <a:noFill/>
+        </p:spPr>
+        <p:txBody>
+          <a:bodyPr wrap="square">
             <a:spAutoFit/>
           </a:bodyPr>
           <a:lstStyle/>
           <a:p>
             <a:pPr>
+              <a:spcAft>
+                <a:spcPts val="800"/>
+              </a:spcAft>
               <a:defRPr sz="2000" b="1">
                 <a:solidFill>
-                  <a:srgbClr val="3B82F6"/>
+                  <a:srgbClr val="333333"/>
                 </a:solidFill>
               </a:defRPr>
             </a:pPr>
             <a:r>
-              <a:t>Multiplication</a:t>
+              <a:t>Addition (+)</a:t>
             </a:r>
           </a:p>
           <a:p>
             <a:pPr>
-              <a:spcBef>
-                <a:spcPts val="600"/>
-              </a:spcBef>
-              <a:defRPr sz="2200">
-                <a:solidFill>
-                  <a:srgbClr val="1E293B"/>
-                </a:solidFill>
-                <a:latin typeface="Courier New"/>
+              <a:spcAft>
+                <a:spcPts val="800"/>
+              </a:spcAft>
+              <a:defRPr sz="2000" b="1">
+                <a:solidFill>
+                  <a:srgbClr val="333333"/>
+                </a:solidFill>
               </a:defRPr>
             </a:pPr>
             <a:r>
-              <a:t>10 * 5  # 50</a:t>
-            </a:r>
-          </a:p>
-        </p:txBody>
-      </p:sp>
-      <p:sp>
-        <p:nvSpPr>
-          <p:cNvPr id="6" name="TextBox 5"/>
-          <p:cNvSpPr txBox="1"/>
-          <p:nvPr/>
-        </p:nvSpPr>
-        <p:spPr>
-          <a:xfrm>
-            <a:off x="4572000" y="1828800"/>
-            <a:ext cx="4114800" cy="1005840"/>
-          </a:xfrm>
-          <a:prstGeom prst="rect">
-            <a:avLst/>
-          </a:prstGeom>
-          <a:solidFill>
-            <a:srgbClr val="DBEAFE"/>
-          </a:solidFill>
-          <a:ln w="25400">
-            <a:solidFill>
-              <a:srgbClr val="3B82F6"/>
-            </a:solidFill>
-          </a:ln>
-        </p:spPr>
-        <p:txBody>
-          <a:bodyPr wrap="none" lIns="182880" tIns="137160">
-            <a:spAutoFit/>
-          </a:bodyPr>
-          <a:lstStyle/>
+              <a:t>Subtraction (-)</a:t>
+            </a:r>
+          </a:p>
           <a:p>
             <a:pPr>
+              <a:spcAft>
+                <a:spcPts val="800"/>
+              </a:spcAft>
               <a:defRPr sz="2000" b="1">
                 <a:solidFill>
-                  <a:srgbClr val="3B82F6"/>
+                  <a:srgbClr val="333333"/>
                 </a:solidFill>
               </a:defRPr>
             </a:pPr>
             <a:r>
-              <a:t>Division</a:t>
+              <a:t>Multiplication (*)</a:t>
             </a:r>
           </a:p>
           <a:p>
             <a:pPr>
-              <a:spcBef>
-                <a:spcPts val="600"/>
-              </a:spcBef>
-              <a:defRPr sz="2200">
-                <a:solidFill>
-                  <a:srgbClr val="1E293B"/>
-                </a:solidFill>
-                <a:latin typeface="Courier New"/>
+              <a:spcAft>
+                <a:spcPts val="800"/>
+              </a:spcAft>
+              <a:defRPr sz="2000" b="1">
+                <a:solidFill>
+                  <a:srgbClr val="333333"/>
+                </a:solidFill>
               </a:defRPr>
             </a:pPr>
             <a:r>
-              <a:t>10 / 5  # 2.0</a:t>
-            </a:r>
-          </a:p>
-        </p:txBody>
-      </p:sp>
-      <p:sp>
-        <p:nvSpPr>
-          <p:cNvPr id="7" name="TextBox 6"/>
-          <p:cNvSpPr txBox="1"/>
-          <p:nvPr/>
-        </p:nvSpPr>
-        <p:spPr>
-          <a:xfrm>
-            <a:off x="4572000" y="3200400"/>
-            <a:ext cx="4114800" cy="1005840"/>
-          </a:xfrm>
-          <a:prstGeom prst="rect">
-            <a:avLst/>
-          </a:prstGeom>
-          <a:solidFill>
-            <a:srgbClr val="DBEAFE"/>
-          </a:solidFill>
-          <a:ln w="25400">
-            <a:solidFill>
-              <a:srgbClr val="3B82F6"/>
-            </a:solidFill>
-          </a:ln>
-        </p:spPr>
-        <p:txBody>
-          <a:bodyPr wrap="none" lIns="182880" tIns="137160">
-            <a:spAutoFit/>
-          </a:bodyPr>
-          <a:lstStyle/>
+              <a:t>Division (/)</a:t>
+            </a:r>
+          </a:p>
           <a:p>
             <a:pPr>
+              <a:spcAft>
+                <a:spcPts val="800"/>
+              </a:spcAft>
               <a:defRPr sz="2000" b="1">
                 <a:solidFill>
-                  <a:srgbClr val="3B82F6"/>
+                  <a:srgbClr val="333333"/>
                 </a:solidFill>
               </a:defRPr>
             </a:pPr>
             <a:r>
-              <a:t>Power</a:t>
+              <a:t>Power (**)</a:t>
             </a:r>
           </a:p>
           <a:p>
             <a:pPr>
-              <a:spcBef>
-                <a:spcPts val="600"/>
-              </a:spcBef>
-              <a:defRPr sz="2200">
-                <a:solidFill>
-                  <a:srgbClr val="1E293B"/>
-                </a:solidFill>
-                <a:latin typeface="Courier New"/>
+              <a:spcAft>
+                <a:spcPts val="800"/>
+              </a:spcAft>
+              <a:defRPr sz="2000" b="1">
+                <a:solidFill>
+                  <a:srgbClr val="333333"/>
+                </a:solidFill>
               </a:defRPr>
             </a:pPr>
             <a:r>
-              <a:t>10 ** 2  # 100</a:t>
-            </a:r>
-          </a:p>
-        </p:txBody>
-      </p:sp>
-      <p:sp>
-        <p:nvSpPr>
-          <p:cNvPr id="8" name="TextBox 7"/>
-          <p:cNvSpPr txBox="1"/>
-          <p:nvPr/>
-        </p:nvSpPr>
-        <p:spPr>
-          <a:xfrm>
-            <a:off x="4572000" y="4572000"/>
-            <a:ext cx="4114800" cy="1005840"/>
-          </a:xfrm>
-          <a:prstGeom prst="rect">
-            <a:avLst/>
-          </a:prstGeom>
-          <a:solidFill>
-            <a:srgbClr val="DBEAFE"/>
-          </a:solidFill>
-          <a:ln w="25400">
-            <a:solidFill>
-              <a:srgbClr val="3B82F6"/>
-            </a:solidFill>
-          </a:ln>
-        </p:spPr>
-        <p:txBody>
-          <a:bodyPr wrap="none" lIns="182880" tIns="137160">
-            <a:spAutoFit/>
-          </a:bodyPr>
-          <a:lstStyle/>
-          <a:p>
-            <a:pPr>
-              <a:defRPr sz="2000" b="1">
-                <a:solidFill>
-                  <a:srgbClr val="3B82F6"/>
-                </a:solidFill>
-              </a:defRPr>
-            </a:pPr>
-            <a:r>
-              <a:t>Remainder</a:t>
-            </a:r>
-          </a:p>
-          <a:p>
-            <a:pPr>
-              <a:spcBef>
-                <a:spcPts val="600"/>
-              </a:spcBef>
-              <a:defRPr sz="2200">
-                <a:solidFill>
-                  <a:srgbClr val="1E293B"/>
-                </a:solidFill>
-                <a:latin typeface="Courier New"/>
-              </a:defRPr>
-            </a:pPr>
-            <a:r>
-              <a:t>10 % 3  # 1</a:t>
+              <a:t>Remainder (%)</a:t>
             </a:r>
           </a:p>
         </p:txBody>
@@ -4973,14 +5222,6 @@
 <file path=ppt/slides/slide8.xml><?xml version="1.0" encoding="utf-8"?>
 <p:sld xmlns:a="http://schemas.openxmlformats.org/drawingml/2006/main" xmlns:p="http://schemas.openxmlformats.org/presentationml/2006/main" xmlns:r="http://schemas.openxmlformats.org/officeDocument/2006/relationships">
   <p:cSld>
-    <p:bg>
-      <p:bgPr>
-        <a:solidFill>
-          <a:srgbClr val="FFFFFF"/>
-        </a:solidFill>
-        <a:effectLst/>
-      </p:bgPr>
-    </p:bg>
     <p:spTree>
       <p:nvGrpSpPr>
         <p:cNvPr id="1" name=""/>
@@ -4990,51 +5231,100 @@
       <p:grpSpPr/>
       <p:sp>
         <p:nvSpPr>
-          <p:cNvPr id="2" name="TextBox 1"/>
-          <p:cNvSpPr txBox="1"/>
+          <p:cNvPr id="2" name="Rectangle 1"/>
+          <p:cNvSpPr/>
           <p:nvPr/>
         </p:nvSpPr>
         <p:spPr>
           <a:xfrm>
             <a:off x="0" y="0"/>
-            <a:ext cx="9144000" cy="1097280"/>
+            <a:ext cx="12191695" cy="6858000"/>
           </a:xfrm>
           <a:prstGeom prst="rect">
             <a:avLst/>
           </a:prstGeom>
           <a:solidFill>
-            <a:srgbClr val="3B82F6"/>
+            <a:srgbClr val="FFFFFF"/>
           </a:solidFill>
-        </p:spPr>
-        <p:txBody>
-          <a:bodyPr wrap="none" tIns="182880">
-            <a:spAutoFit/>
-          </a:bodyPr>
-          <a:lstStyle/>
-          <a:p>
-            <a:pPr algn="ctr">
-              <a:defRPr sz="4400" b="1">
-                <a:solidFill>
-                  <a:srgbClr val="FFFFFF"/>
-                </a:solidFill>
-              </a:defRPr>
-            </a:pPr>
-            <a:r>
-              <a:t>The print() Function</a:t>
-            </a:r>
-          </a:p>
-        </p:txBody>
-      </p:sp>
-      <p:sp>
-        <p:nvSpPr>
-          <p:cNvPr id="3" name="TextBox 2"/>
+          <a:ln>
+            <a:noFill/>
+          </a:ln>
+        </p:spPr>
+        <p:style>
+          <a:lnRef idx="1">
+            <a:schemeClr val="accent1"/>
+          </a:lnRef>
+          <a:fillRef idx="3">
+            <a:schemeClr val="accent1"/>
+          </a:fillRef>
+          <a:effectRef idx="2">
+            <a:schemeClr val="accent1"/>
+          </a:effectRef>
+          <a:fontRef idx="minor">
+            <a:schemeClr val="lt1"/>
+          </a:fontRef>
+        </p:style>
+        <p:txBody>
+          <a:bodyPr rtlCol="0" anchor="ctr"/>
+          <a:lstStyle/>
+          <a:p>
+            <a:pPr algn="ctr"/>
+          </a:p>
+        </p:txBody>
+      </p:sp>
+      <p:sp>
+        <p:nvSpPr>
+          <p:cNvPr id="3" name="Rectangle 2"/>
+          <p:cNvSpPr/>
+          <p:nvPr/>
+        </p:nvSpPr>
+        <p:spPr>
+          <a:xfrm>
+            <a:off x="0" y="0"/>
+            <a:ext cx="12191695" cy="137160"/>
+          </a:xfrm>
+          <a:prstGeom prst="rect">
+            <a:avLst/>
+          </a:prstGeom>
+          <a:solidFill>
+            <a:srgbClr val="0066CC"/>
+          </a:solidFill>
+          <a:ln>
+            <a:noFill/>
+          </a:ln>
+        </p:spPr>
+        <p:style>
+          <a:lnRef idx="1">
+            <a:schemeClr val="accent1"/>
+          </a:lnRef>
+          <a:fillRef idx="3">
+            <a:schemeClr val="accent1"/>
+          </a:fillRef>
+          <a:effectRef idx="2">
+            <a:schemeClr val="accent1"/>
+          </a:effectRef>
+          <a:fontRef idx="minor">
+            <a:schemeClr val="lt1"/>
+          </a:fontRef>
+        </p:style>
+        <p:txBody>
+          <a:bodyPr rtlCol="0" anchor="ctr"/>
+          <a:lstStyle/>
+          <a:p>
+            <a:pPr algn="ctr"/>
+          </a:p>
+        </p:txBody>
+      </p:sp>
+      <p:sp>
+        <p:nvSpPr>
+          <p:cNvPr id="4" name="TextBox 3"/>
           <p:cNvSpPr txBox="1"/>
           <p:nvPr/>
         </p:nvSpPr>
         <p:spPr>
           <a:xfrm>
-            <a:off x="914400" y="1645920"/>
-            <a:ext cx="7315200" cy="548640"/>
+            <a:off x="457200" y="365760"/>
+            <a:ext cx="10972800" cy="731520"/>
           </a:xfrm>
           <a:prstGeom prst="rect">
             <a:avLst/>
@@ -5047,191 +5337,111 @@
           </a:bodyPr>
           <a:lstStyle/>
           <a:p>
-            <a:pPr algn="ctr">
-              <a:defRPr sz="2200">
-                <a:solidFill>
-                  <a:srgbClr val="1E293B"/>
+            <a:pPr>
+              <a:defRPr sz="4000" b="1">
+                <a:solidFill>
+                  <a:srgbClr val="003366"/>
                 </a:solidFill>
               </a:defRPr>
             </a:pPr>
             <a:r>
-              <a:t>Display output to the screen</a:t>
-            </a:r>
-          </a:p>
-        </p:txBody>
-      </p:sp>
-      <p:sp>
-        <p:nvSpPr>
-          <p:cNvPr id="4" name="TextBox 3"/>
-          <p:cNvSpPr txBox="1"/>
+              <a:t>Displaying Output: print() 🖨️</a:t>
+            </a:r>
+          </a:p>
+        </p:txBody>
+      </p:sp>
+      <p:sp>
+        <p:nvSpPr>
+          <p:cNvPr id="5" name="Rectangle 4"/>
+          <p:cNvSpPr/>
           <p:nvPr/>
         </p:nvSpPr>
         <p:spPr>
           <a:xfrm>
-            <a:off x="1371600" y="2560320"/>
-            <a:ext cx="6400800" cy="731520"/>
+            <a:off x="457200" y="1005840"/>
+            <a:ext cx="1828800" cy="45720"/>
           </a:xfrm>
           <a:prstGeom prst="rect">
             <a:avLst/>
           </a:prstGeom>
           <a:solidFill>
-            <a:srgbClr val="DBEAFE"/>
+            <a:srgbClr val="0066CC"/>
           </a:solidFill>
-          <a:ln w="25400">
-            <a:solidFill>
-              <a:srgbClr val="3B82F6"/>
-            </a:solidFill>
+          <a:ln>
+            <a:noFill/>
           </a:ln>
         </p:spPr>
-        <p:txBody>
-          <a:bodyPr wrap="square" lIns="182880" tIns="137160">
-            <a:spAutoFit/>
-          </a:bodyPr>
-          <a:lstStyle/>
-          <a:p>
-            <a:pPr>
-              <a:defRPr sz="2200">
-                <a:solidFill>
-                  <a:srgbClr val="1E293B"/>
-                </a:solidFill>
-                <a:latin typeface="Courier New"/>
-              </a:defRPr>
-            </a:pPr>
-            <a:r>
-              <a:t>print("Hello, World!")</a:t>
-            </a:r>
-          </a:p>
-        </p:txBody>
-      </p:sp>
-      <p:sp>
-        <p:nvSpPr>
-          <p:cNvPr id="5" name="TextBox 4"/>
+        <p:style>
+          <a:lnRef idx="1">
+            <a:schemeClr val="accent1"/>
+          </a:lnRef>
+          <a:fillRef idx="3">
+            <a:schemeClr val="accent1"/>
+          </a:fillRef>
+          <a:effectRef idx="2">
+            <a:schemeClr val="accent1"/>
+          </a:effectRef>
+          <a:fontRef idx="minor">
+            <a:schemeClr val="lt1"/>
+          </a:fontRef>
+        </p:style>
+        <p:txBody>
+          <a:bodyPr rtlCol="0" anchor="ctr"/>
+          <a:lstStyle/>
+          <a:p>
+            <a:pPr algn="ctr"/>
+          </a:p>
+        </p:txBody>
+      </p:sp>
+      <p:sp>
+        <p:nvSpPr>
+          <p:cNvPr id="6" name="TextBox 5"/>
           <p:cNvSpPr txBox="1"/>
           <p:nvPr/>
         </p:nvSpPr>
         <p:spPr>
           <a:xfrm>
-            <a:off x="1371600" y="3474720"/>
-            <a:ext cx="6400800" cy="731520"/>
+            <a:off x="640080" y="1371600"/>
+            <a:ext cx="10789920" cy="4572000"/>
           </a:xfrm>
           <a:prstGeom prst="rect">
             <a:avLst/>
           </a:prstGeom>
-          <a:solidFill>
-            <a:srgbClr val="DBEAFE"/>
-          </a:solidFill>
-          <a:ln w="25400">
-            <a:solidFill>
-              <a:srgbClr val="3B82F6"/>
-            </a:solidFill>
-          </a:ln>
-        </p:spPr>
-        <p:txBody>
-          <a:bodyPr wrap="square" lIns="182880" tIns="137160">
+          <a:noFill/>
+        </p:spPr>
+        <p:txBody>
+          <a:bodyPr wrap="square">
             <a:spAutoFit/>
           </a:bodyPr>
           <a:lstStyle/>
           <a:p>
             <a:pPr>
-              <a:defRPr sz="2200">
-                <a:solidFill>
-                  <a:srgbClr val="1E293B"/>
-                </a:solidFill>
-                <a:latin typeface="Courier New"/>
+              <a:spcAft>
+                <a:spcPts val="800"/>
+              </a:spcAft>
+              <a:defRPr sz="2000" b="1">
+                <a:solidFill>
+                  <a:srgbClr val="333333"/>
+                </a:solidFill>
               </a:defRPr>
             </a:pPr>
             <a:r>
-              <a:t>print(42)</a:t>
-            </a:r>
-          </a:p>
-        </p:txBody>
-      </p:sp>
-      <p:sp>
-        <p:nvSpPr>
-          <p:cNvPr id="6" name="TextBox 5"/>
-          <p:cNvSpPr txBox="1"/>
-          <p:nvPr/>
-        </p:nvSpPr>
-        <p:spPr>
-          <a:xfrm>
-            <a:off x="1371600" y="4389120"/>
-            <a:ext cx="6400800" cy="731520"/>
-          </a:xfrm>
-          <a:prstGeom prst="rect">
-            <a:avLst/>
-          </a:prstGeom>
-          <a:solidFill>
-            <a:srgbClr val="DBEAFE"/>
-          </a:solidFill>
-          <a:ln w="25400">
-            <a:solidFill>
-              <a:srgbClr val="3B82F6"/>
-            </a:solidFill>
-          </a:ln>
-        </p:spPr>
-        <p:txBody>
-          <a:bodyPr wrap="square" lIns="182880" tIns="137160">
-            <a:spAutoFit/>
-          </a:bodyPr>
-          <a:lstStyle/>
+              <a:t>The print() function displays information on the screen</a:t>
+            </a:r>
+          </a:p>
           <a:p>
             <a:pPr>
-              <a:defRPr sz="2200">
-                <a:solidFill>
-                  <a:srgbClr val="1E293B"/>
-                </a:solidFill>
-                <a:latin typeface="Courier New"/>
+              <a:spcAft>
+                <a:spcPts val="800"/>
+              </a:spcAft>
+              <a:defRPr sz="2000" b="1">
+                <a:solidFill>
+                  <a:srgbClr val="333333"/>
+                </a:solidFill>
               </a:defRPr>
             </a:pPr>
             <a:r>
-              <a:t>name = "Alice"</a:t>
-            </a:r>
-            <a:br/>
-            <a:r>
-              <a:t>print(name)</a:t>
-            </a:r>
-          </a:p>
-        </p:txBody>
-      </p:sp>
-      <p:sp>
-        <p:nvSpPr>
-          <p:cNvPr id="7" name="TextBox 6"/>
-          <p:cNvSpPr txBox="1"/>
-          <p:nvPr/>
-        </p:nvSpPr>
-        <p:spPr>
-          <a:xfrm>
-            <a:off x="1371600" y="5303520"/>
-            <a:ext cx="6400800" cy="731520"/>
-          </a:xfrm>
-          <a:prstGeom prst="rect">
-            <a:avLst/>
-          </a:prstGeom>
-          <a:solidFill>
-            <a:srgbClr val="DBEAFE"/>
-          </a:solidFill>
-          <a:ln w="25400">
-            <a:solidFill>
-              <a:srgbClr val="3B82F6"/>
-            </a:solidFill>
-          </a:ln>
-        </p:spPr>
-        <p:txBody>
-          <a:bodyPr wrap="square" lIns="182880" tIns="137160">
-            <a:spAutoFit/>
-          </a:bodyPr>
-          <a:lstStyle/>
-          <a:p>
-            <a:pPr>
-              <a:defRPr sz="2200">
-                <a:solidFill>
-                  <a:srgbClr val="1E293B"/>
-                </a:solidFill>
-                <a:latin typeface="Courier New"/>
-              </a:defRPr>
-            </a:pPr>
-            <a:r>
-              <a:t>print(10 + 5)</a:t>
+              <a:t>Examples:</a:t>
             </a:r>
           </a:p>
         </p:txBody>
@@ -5247,14 +5457,6 @@
 <file path=ppt/slides/slide9.xml><?xml version="1.0" encoding="utf-8"?>
 <p:sld xmlns:a="http://schemas.openxmlformats.org/drawingml/2006/main" xmlns:p="http://schemas.openxmlformats.org/presentationml/2006/main" xmlns:r="http://schemas.openxmlformats.org/officeDocument/2006/relationships">
   <p:cSld>
-    <p:bg>
-      <p:bgPr>
-        <a:solidFill>
-          <a:srgbClr val="FFFFFF"/>
-        </a:solidFill>
-        <a:effectLst/>
-      </p:bgPr>
-    </p:bg>
     <p:spTree>
       <p:nvGrpSpPr>
         <p:cNvPr id="1" name=""/>
@@ -5264,51 +5466,100 @@
       <p:grpSpPr/>
       <p:sp>
         <p:nvSpPr>
-          <p:cNvPr id="2" name="TextBox 1"/>
-          <p:cNvSpPr txBox="1"/>
+          <p:cNvPr id="2" name="Rectangle 1"/>
+          <p:cNvSpPr/>
           <p:nvPr/>
         </p:nvSpPr>
         <p:spPr>
           <a:xfrm>
             <a:off x="0" y="0"/>
-            <a:ext cx="9144000" cy="1097280"/>
+            <a:ext cx="12191695" cy="6858000"/>
           </a:xfrm>
           <a:prstGeom prst="rect">
             <a:avLst/>
           </a:prstGeom>
           <a:solidFill>
-            <a:srgbClr val="3B82F6"/>
+            <a:srgbClr val="FFFFFF"/>
           </a:solidFill>
-        </p:spPr>
-        <p:txBody>
-          <a:bodyPr wrap="none" tIns="182880">
-            <a:spAutoFit/>
-          </a:bodyPr>
-          <a:lstStyle/>
-          <a:p>
-            <a:pPr algn="ctr">
-              <a:defRPr sz="4400" b="1">
-                <a:solidFill>
-                  <a:srgbClr val="FFFFFF"/>
-                </a:solidFill>
-              </a:defRPr>
-            </a:pPr>
-            <a:r>
-              <a:t>Putting It All Together</a:t>
-            </a:r>
-          </a:p>
-        </p:txBody>
-      </p:sp>
-      <p:sp>
-        <p:nvSpPr>
-          <p:cNvPr id="3" name="TextBox 2"/>
+          <a:ln>
+            <a:noFill/>
+          </a:ln>
+        </p:spPr>
+        <p:style>
+          <a:lnRef idx="1">
+            <a:schemeClr val="accent1"/>
+          </a:lnRef>
+          <a:fillRef idx="3">
+            <a:schemeClr val="accent1"/>
+          </a:fillRef>
+          <a:effectRef idx="2">
+            <a:schemeClr val="accent1"/>
+          </a:effectRef>
+          <a:fontRef idx="minor">
+            <a:schemeClr val="lt1"/>
+          </a:fontRef>
+        </p:style>
+        <p:txBody>
+          <a:bodyPr rtlCol="0" anchor="ctr"/>
+          <a:lstStyle/>
+          <a:p>
+            <a:pPr algn="ctr"/>
+          </a:p>
+        </p:txBody>
+      </p:sp>
+      <p:sp>
+        <p:nvSpPr>
+          <p:cNvPr id="3" name="Rectangle 2"/>
+          <p:cNvSpPr/>
+          <p:nvPr/>
+        </p:nvSpPr>
+        <p:spPr>
+          <a:xfrm>
+            <a:off x="0" y="0"/>
+            <a:ext cx="12191695" cy="137160"/>
+          </a:xfrm>
+          <a:prstGeom prst="rect">
+            <a:avLst/>
+          </a:prstGeom>
+          <a:solidFill>
+            <a:srgbClr val="0066CC"/>
+          </a:solidFill>
+          <a:ln>
+            <a:noFill/>
+          </a:ln>
+        </p:spPr>
+        <p:style>
+          <a:lnRef idx="1">
+            <a:schemeClr val="accent1"/>
+          </a:lnRef>
+          <a:fillRef idx="3">
+            <a:schemeClr val="accent1"/>
+          </a:fillRef>
+          <a:effectRef idx="2">
+            <a:schemeClr val="accent1"/>
+          </a:effectRef>
+          <a:fontRef idx="minor">
+            <a:schemeClr val="lt1"/>
+          </a:fontRef>
+        </p:style>
+        <p:txBody>
+          <a:bodyPr rtlCol="0" anchor="ctr"/>
+          <a:lstStyle/>
+          <a:p>
+            <a:pPr algn="ctr"/>
+          </a:p>
+        </p:txBody>
+      </p:sp>
+      <p:sp>
+        <p:nvSpPr>
+          <p:cNvPr id="4" name="TextBox 3"/>
           <p:cNvSpPr txBox="1"/>
           <p:nvPr/>
         </p:nvSpPr>
         <p:spPr>
           <a:xfrm>
-            <a:off x="914400" y="1463040"/>
-            <a:ext cx="7315200" cy="457200"/>
+            <a:off x="457200" y="365760"/>
+            <a:ext cx="10972800" cy="731520"/>
           </a:xfrm>
           <a:prstGeom prst="rect">
             <a:avLst/>
@@ -5321,100 +5572,96 @@
           </a:bodyPr>
           <a:lstStyle/>
           <a:p>
-            <a:pPr algn="ctr">
-              <a:defRPr sz="2600" b="1">
-                <a:solidFill>
-                  <a:srgbClr val="3B82F6"/>
+            <a:pPr>
+              <a:defRPr sz="4000" b="1">
+                <a:solidFill>
+                  <a:srgbClr val="003366"/>
                 </a:solidFill>
               </a:defRPr>
             </a:pPr>
             <a:r>
-              <a:t>A Simple Calculator Example</a:t>
-            </a:r>
-          </a:p>
-        </p:txBody>
-      </p:sp>
-      <p:sp>
-        <p:nvSpPr>
-          <p:cNvPr id="4" name="TextBox 3"/>
-          <p:cNvSpPr txBox="1"/>
+              <a:t>Let's Build Something! 🔨</a:t>
+            </a:r>
+          </a:p>
+        </p:txBody>
+      </p:sp>
+      <p:sp>
+        <p:nvSpPr>
+          <p:cNvPr id="5" name="Rectangle 4"/>
+          <p:cNvSpPr/>
           <p:nvPr/>
         </p:nvSpPr>
         <p:spPr>
           <a:xfrm>
-            <a:off x="1097280" y="2286000"/>
-            <a:ext cx="6949440" cy="3840480"/>
+            <a:off x="457200" y="1005840"/>
+            <a:ext cx="1828800" cy="45720"/>
           </a:xfrm>
           <a:prstGeom prst="rect">
             <a:avLst/>
           </a:prstGeom>
           <a:solidFill>
-            <a:srgbClr val="DBEAFE"/>
+            <a:srgbClr val="0066CC"/>
           </a:solidFill>
-          <a:ln w="38100">
-            <a:solidFill>
-              <a:srgbClr val="3B82F6"/>
-            </a:solidFill>
+          <a:ln>
+            <a:noFill/>
           </a:ln>
         </p:spPr>
-        <p:txBody>
-          <a:bodyPr wrap="square" lIns="274320" tIns="274320">
+        <p:style>
+          <a:lnRef idx="1">
+            <a:schemeClr val="accent1"/>
+          </a:lnRef>
+          <a:fillRef idx="3">
+            <a:schemeClr val="accent1"/>
+          </a:fillRef>
+          <a:effectRef idx="2">
+            <a:schemeClr val="accent1"/>
+          </a:effectRef>
+          <a:fontRef idx="minor">
+            <a:schemeClr val="lt1"/>
+          </a:fontRef>
+        </p:style>
+        <p:txBody>
+          <a:bodyPr rtlCol="0" anchor="ctr"/>
+          <a:lstStyle/>
+          <a:p>
+            <a:pPr algn="ctr"/>
+          </a:p>
+        </p:txBody>
+      </p:sp>
+      <p:sp>
+        <p:nvSpPr>
+          <p:cNvPr id="6" name="TextBox 5"/>
+          <p:cNvSpPr txBox="1"/>
+          <p:nvPr/>
+        </p:nvSpPr>
+        <p:spPr>
+          <a:xfrm>
+            <a:off x="640080" y="1371600"/>
+            <a:ext cx="10789920" cy="4572000"/>
+          </a:xfrm>
+          <a:prstGeom prst="rect">
+            <a:avLst/>
+          </a:prstGeom>
+          <a:noFill/>
+        </p:spPr>
+        <p:txBody>
+          <a:bodyPr wrap="square">
             <a:spAutoFit/>
           </a:bodyPr>
           <a:lstStyle/>
           <a:p>
             <a:pPr>
-              <a:defRPr sz="2000">
-                <a:solidFill>
-                  <a:srgbClr val="1E293B"/>
-                </a:solidFill>
-                <a:latin typeface="Courier New"/>
+              <a:spcAft>
+                <a:spcPts val="800"/>
+              </a:spcAft>
+              <a:defRPr sz="2000" b="1">
+                <a:solidFill>
+                  <a:srgbClr val="333333"/>
+                </a:solidFill>
               </a:defRPr>
             </a:pPr>
             <a:r>
-              <a:t># Store numbers in variables</a:t>
-            </a:r>
-            <a:br/>
-            <a:r>
-              <a:t>num1 = 10</a:t>
-            </a:r>
-            <a:br/>
-            <a:r>
-              <a:t>num2 = 5</a:t>
-            </a:r>
-            <a:br/>
-            <a:br/>
-            <a:r>
-              <a:t># Perform calculations</a:t>
-            </a:r>
-            <a:br/>
-            <a:r>
-              <a:t>sum_result = num1 + num2</a:t>
-            </a:r>
-            <a:br/>
-            <a:r>
-              <a:t>difference = num1 - num2</a:t>
-            </a:r>
-            <a:br/>
-            <a:r>
-              <a:t>product = num1 * num2</a:t>
-            </a:r>
-            <a:br/>
-            <a:br/>
-            <a:r>
-              <a:t># Display results</a:t>
-            </a:r>
-            <a:br/>
-            <a:r>
-              <a:t>print("Sum:", sum_result)</a:t>
-            </a:r>
-            <a:br/>
-            <a:r>
-              <a:t>print("Difference:", difference)</a:t>
-            </a:r>
-            <a:br/>
-            <a:r>
-              <a:t>print("Product:", product)</a:t>
+              <a:t>A Simple Calculator</a:t>
             </a:r>
           </a:p>
         </p:txBody>

</xml_diff>